<commit_message>
Add speaker notes and align presentation metrics with evaluation results
- Embed per-slide speaker notes (~8 min) in ADO_powerpoint_presentation.pptx
- Add docs/Presentation_Speaker_Notes.md with full script, split, and Q&A prep
- Update slide 9 with Track 2/3 footnote metrics and clarified ablation wording
- Add script to regenerate notes from source

Co-authored-by: patrickwalsh26 <patrickwalsh26@users.noreply.github.com>
</commit_message>
<xml_diff>
--- a/ADO_powerpoint_presentation.pptx
+++ b/ADO_powerpoint_presentation.pptx
@@ -1518,20 +1518,21 @@
           </a:bodyPr>
           <a:lstStyle/>
           <a:p>
-            <a:pPr indent="0" lvl="0" marL="0" rtl="0" algn="l">
-              <a:spcBef>
-                <a:spcPts val="0"/>
-              </a:spcBef>
-              <a:spcAft>
-                <a:spcPts val="0"/>
-              </a:spcAft>
-              <a:buNone/>
-            </a:pPr>
-            <a:r>
-              <a:rPr lang="en-US"/>
-              <a:t>Presenter note: Slide 1 summarizes the ADO final report and is designed for a concise project presentation.</a:t>
-            </a:r>
-            <a:endParaRPr/>
+            <a:r>
+              <a:t>[~30s] Good morning. Patrick Walsh and Darren Chan, Stanford BMDS 210 / CS 270.</a:t>
+            </a:r>
+          </a:p>
+          <a:p/>
+          <a:p>
+            <a:r>
+              <a:t>Hook: ADO is a computable OWL 2 representation of end-of-life preferences in advanced heart failure—not a legal advance directive, but a decision-support layer that helps clinicians reason over what patients said and pre-populate ACP documentation.</a:t>
+            </a:r>
+          </a:p>
+          <a:p/>
+          <a:p>
+            <a:r>
+              <a:t>Transition → why the bedside workflow breaks down.</a:t>
+            </a:r>
           </a:p>
         </p:txBody>
       </p:sp>
@@ -1676,20 +1677,31 @@
           </a:bodyPr>
           <a:lstStyle/>
           <a:p>
-            <a:pPr indent="0" lvl="0" marL="0" rtl="0" algn="l">
-              <a:spcBef>
-                <a:spcPts val="0"/>
-              </a:spcBef>
-              <a:spcAft>
-                <a:spcPts val="0"/>
-              </a:spcAft>
-              <a:buNone/>
-            </a:pPr>
-            <a:r>
-              <a:rPr lang="en-US"/>
-              <a:t>Presenter note: Slide 10 summarizes the ADO final report and is designed for a concise project presentation.</a:t>
-            </a:r>
-            <a:endParaRPr/>
+            <a:r>
+              <a:t>[~50s] Same directive, two scenarios:</a:t>
+            </a:r>
+          </a:p>
+          <a:p>
+            <a:r>
+              <a:t>A: NYHA IV + no reversible cause → DNR, clear.</a:t>
+            </a:r>
+          </a:p>
+          <a:p>
+            <a:r>
+              <a:t>B: NYHA III + reversible cause → Full code, partial.</a:t>
+            </a:r>
+          </a:p>
+          <a:p/>
+          <a:p>
+            <a:r>
+              <a:t>Flat POLST/checkbox must over-apply or discard the condition. ADO preserves if/then and flags when it applies.</a:t>
+            </a:r>
+          </a:p>
+          <a:p/>
+          <a:p>
+            <a:r>
+              <a:t>Transition → where this lives clinically.</a:t>
+            </a:r>
           </a:p>
         </p:txBody>
       </p:sp>
@@ -1834,20 +1846,33 @@
           </a:bodyPr>
           <a:lstStyle/>
           <a:p>
-            <a:pPr indent="0" lvl="0" marL="0" rtl="0" algn="l">
-              <a:spcBef>
-                <a:spcPts val="0"/>
-              </a:spcBef>
-              <a:spcAft>
-                <a:spcPts val="0"/>
-              </a:spcAft>
-              <a:buNone/>
-            </a:pPr>
-            <a:r>
-              <a:rPr lang="en-US"/>
-              <a:t>Presenter note: Slide 11 summarizes the ADO final report and is designed for a concise project presentation.</a:t>
-            </a:r>
-            <a:endParaRPr/>
+            <a:r>
+              <a:t>[~40s] Dr. David Magnus (Stanford Biomedical Ethics): “You can’t think of these as AHCDs… more like a progress note.”</a:t>
+            </a:r>
+          </a:p>
+          <a:p/>
+          <a:p>
+            <a:r>
+              <a:t>Near-term product: pre-populate Epic-style ACP note → provider conversation can clarify/override → final ACP + POLST/code status.</a:t>
+            </a:r>
+          </a:p>
+          <a:p/>
+          <a:p>
+            <a:r>
+              <a:t>Not a legal directive; complements POLST and code status.</a:t>
+            </a:r>
+          </a:p>
+          <a:p/>
+          <a:p>
+            <a:r>
+              <a:t>If asked: next modeling gap is WHO decides (surrogate override), not just WHAT intervention.</a:t>
+            </a:r>
+          </a:p>
+          <a:p/>
+          <a:p>
+            <a:r>
+              <a:t>Transition → limitations.</a:t>
+            </a:r>
           </a:p>
         </p:txBody>
       </p:sp>
@@ -1992,20 +2017,40 @@
           </a:bodyPr>
           <a:lstStyle/>
           <a:p>
-            <a:pPr indent="0" lvl="0" marL="0" rtl="0" algn="l">
-              <a:spcBef>
-                <a:spcPts val="0"/>
-              </a:spcBef>
-              <a:spcAft>
-                <a:spcPts val="0"/>
-              </a:spcAft>
-              <a:buNone/>
-            </a:pPr>
-            <a:r>
-              <a:rPr lang="en-US"/>
-              <a:t>Presenter note: Slide 12 summarizes the ADO final report and is designed for a concise project presentation.</a:t>
-            </a:r>
-            <a:endParaRPr/>
+            <a:r>
+              <a:t>[~40s] Honest limits:</a:t>
+            </a:r>
+          </a:p>
+          <a:p>
+            <a:r>
+              <a:t>• No legal force</a:t>
+            </a:r>
+          </a:p>
+          <a:p>
+            <a:r>
+              <a:t>• One-dimensional (what, not who decides) — top priority extension</a:t>
+            </a:r>
+          </a:p>
+          <a:p>
+            <a:r>
+              <a:t>• Coverage gaps: artificial nutrition, antibiotics, comfort care</a:t>
+            </a:r>
+          </a:p>
+          <a:p>
+            <a:r>
+              <a:t>• Temporal: numeric hour bounds, not full temporal logic</a:t>
+            </a:r>
+          </a:p>
+          <a:p>
+            <a:r>
+              <a:t>• Gold standards team-authored; real EHR validation (MIMIC-IV) future</a:t>
+            </a:r>
+          </a:p>
+          <a:p/>
+          <a:p>
+            <a:r>
+              <a:t>Principle: surface uncertainty; don’t replace clinicians/surrogates.</a:t>
+            </a:r>
           </a:p>
         </p:txBody>
       </p:sp>
@@ -2150,20 +2195,26 @@
           </a:bodyPr>
           <a:lstStyle/>
           <a:p>
-            <a:pPr indent="0" lvl="0" marL="0" rtl="0" algn="l">
-              <a:spcBef>
-                <a:spcPts val="0"/>
-              </a:spcBef>
-              <a:spcAft>
-                <a:spcPts val="0"/>
-              </a:spcAft>
-              <a:buNone/>
-            </a:pPr>
-            <a:r>
-              <a:rPr lang="en-US"/>
-              <a:t>Presenter note: Slide 13 summarizes the ADO final report and is designed for a concise project presentation.</a:t>
-            </a:r>
-            <a:endParaRPr/>
+            <a:r>
+              <a:t>[~30s] Four takeaways on slide—read them, don’t rush.</a:t>
+            </a:r>
+          </a:p>
+          <a:p/>
+          <a:p>
+            <a:r>
+              <a:t>Close: Questions welcome.</a:t>
+            </a:r>
+          </a:p>
+          <a:p>
+            <a:r>
+              <a:t>Repo: https://github.com/patrickwalsh26/bmds210-AD_Ontology</a:t>
+            </a:r>
+          </a:p>
+          <a:p/>
+          <a:p>
+            <a:r>
+              <a:t>Q&amp;A prep: legal AD? No. Why not LLM only? Over-confident, not auditable. Weakest point? Team gold + P5 principled divergence.</a:t>
+            </a:r>
           </a:p>
         </p:txBody>
       </p:sp>
@@ -2308,20 +2359,33 @@
           </a:bodyPr>
           <a:lstStyle/>
           <a:p>
-            <a:pPr indent="0" lvl="0" marL="0" rtl="0" algn="l">
-              <a:spcBef>
-                <a:spcPts val="0"/>
-              </a:spcBef>
-              <a:spcAft>
-                <a:spcPts val="0"/>
-              </a:spcAft>
-              <a:buNone/>
-            </a:pPr>
-            <a:r>
-              <a:rPr lang="en-US"/>
-              <a:t>Presenter note: Slide 2 summarizes the ADO final report and is designed for a concise project presentation.</a:t>
-            </a:r>
-            <a:endParaRPr/>
+            <a:r>
+              <a:t>[~45s] Three instruments, three jobs: advance directive (values/wishes), POLST (portable orders), code status (what we act on at 2 a.m.).</a:t>
+            </a:r>
+          </a:p>
+          <a:p/>
+          <a:p>
+            <a:r>
+              <a:t>The loss is in the middle—conditional wishes become coarse checkboxes or bedside orders.</a:t>
+            </a:r>
+          </a:p>
+          <a:p/>
+          <a:p>
+            <a:r>
+              <a:t>Important reframe (Magnus): the problem is NOT mainly “unreadable free text.” CA and UC forms are mostly checkboxes. They are low-resolution and disease-blind.</a:t>
+            </a:r>
+          </a:p>
+          <a:p/>
+          <a:p>
+            <a:r>
+              <a:t>Point to the ventilator example: temporary-if-reversible vs never-indefinitely cannot fit a yes/no box.</a:t>
+            </a:r>
+          </a:p>
+          <a:p/>
+          <a:p>
+            <a:r>
+              <a:t>Transition → why we scoped to advanced HF.</a:t>
+            </a:r>
           </a:p>
         </p:txBody>
       </p:sp>
@@ -2466,20 +2530,27 @@
           </a:bodyPr>
           <a:lstStyle/>
           <a:p>
-            <a:pPr indent="0" lvl="0" marL="0" rtl="0" algn="l">
-              <a:spcBef>
-                <a:spcPts val="0"/>
-              </a:spcBef>
-              <a:spcAft>
-                <a:spcPts val="0"/>
-              </a:spcAft>
-              <a:buNone/>
-            </a:pPr>
-            <a:r>
-              <a:rPr lang="en-US"/>
-              <a:t>Presenter note: Slide 3 summarizes the ADO final report and is designed for a concise project presentation.</a:t>
-            </a:r>
-            <a:endParaRPr/>
+            <a:r>
+              <a:t>[~40s] HF is unpredictable, device-dependent, and patients revisit the ED/ICU—preference interpretation is time-pressured and repeated.</a:t>
+            </a:r>
+          </a:p>
+          <a:p/>
+          <a:p>
+            <a:r>
+              <a:t>Five decision points on slide: CPR, ventilation, devices, vasopressors/inotropes, dialysis.</a:t>
+            </a:r>
+          </a:p>
+          <a:p/>
+          <a:p>
+            <a:r>
+              <a:t>~200K HF patients have ICDs; generic ADs rarely mention ICD/LVAD/inotropes—that gap motivates our scope.</a:t>
+            </a:r>
+          </a:p>
+          <a:p/>
+          <a:p>
+            <a:r>
+              <a:t>Transition → how we represent a preference computationally.</a:t>
+            </a:r>
           </a:p>
         </p:txBody>
       </p:sp>
@@ -2624,20 +2695,27 @@
           </a:bodyPr>
           <a:lstStyle/>
           <a:p>
-            <a:pPr indent="0" lvl="0" marL="0" rtl="0" algn="l">
-              <a:spcBef>
-                <a:spcPts val="0"/>
-              </a:spcBef>
-              <a:spcAft>
-                <a:spcPts val="0"/>
-              </a:spcAft>
-              <a:buNone/>
-            </a:pPr>
-            <a:r>
-              <a:rPr lang="en-US"/>
-              <a:t>Presenter note: Slide 4 summarizes the ADO final report and is designed for a concise project presentation.</a:t>
-            </a:r>
-            <a:endParaRPr/>
+            <a:r>
+              <a:t>[~45s] Core unit: PreferenceStatement = intervention + activation conditions + strength + negation + verbatim originalText.</a:t>
+            </a:r>
+          </a:p>
+          <a:p/>
+          <a:p>
+            <a:r>
+              <a:t>Walk the vasopressor example: 72h “no improvement” becomes a structured activation condition the reasoner can test.</a:t>
+            </a:r>
+          </a:p>
+          <a:p/>
+          <a:p>
+            <a:r>
+              <a:t>Why verbatim text? Auditable—clinicians see patient language behind the inference.</a:t>
+            </a:r>
+          </a:p>
+          <a:p/>
+          <a:p>
+            <a:r>
+              <a:t>Transition → ontology size and granularity.</a:t>
+            </a:r>
           </a:p>
         </p:txBody>
       </p:sp>
@@ -2782,20 +2860,21 @@
           </a:bodyPr>
           <a:lstStyle/>
           <a:p>
-            <a:pPr indent="0" lvl="0" marL="0" rtl="0" algn="l">
-              <a:spcBef>
-                <a:spcPts val="0"/>
-              </a:spcBef>
-              <a:spcAft>
-                <a:spcPts val="0"/>
-              </a:spcAft>
-              <a:buNone/>
-            </a:pPr>
-            <a:r>
-              <a:rPr lang="en-US"/>
-              <a:t>Presenter note: Slide 5 summarizes the ADO final report and is designed for a concise project presentation.</a:t>
-            </a:r>
-            <a:endParaRPr/>
+            <a:r>
+              <a:t>[~40s] 67 classes, 22 properties, 21 intervention subclasses—finer than any single template in our 50-form inventory (e.g., six ventilation types vs one checkbox).</a:t>
+            </a:r>
+          </a:p>
+          <a:p/>
+          <a:p>
+            <a:r>
+              <a:t>SNOMED CT grounding where possible for interoperability.</a:t>
+            </a:r>
+          </a:p>
+          <a:p/>
+          <a:p>
+            <a:r>
+              <a:t>Transition → we don’t force binary answers.</a:t>
+            </a:r>
           </a:p>
         </p:txBody>
       </p:sp>
@@ -2940,20 +3019,41 @@
           </a:bodyPr>
           <a:lstStyle/>
           <a:p>
-            <a:pPr indent="0" lvl="0" marL="0" rtl="0" algn="l">
-              <a:spcBef>
-                <a:spcPts val="0"/>
-              </a:spcBef>
-              <a:spcAft>
-                <a:spcPts val="0"/>
-              </a:spcAft>
-              <a:buNone/>
-            </a:pPr>
-            <a:r>
-              <a:rPr lang="en-US"/>
-              <a:t>Presenter note: Slide 6 summarizes the ADO final report and is designed for a concise project presentation.</a:t>
-            </a:r>
-            <a:endParaRPr/>
+            <a:r>
+              <a:t>[~45s] Four honest outputs:</a:t>
+            </a:r>
+          </a:p>
+          <a:p>
+            <a:r>
+              <a:t>• Clear — conditions met, unambiguous</a:t>
+            </a:r>
+          </a:p>
+          <a:p>
+            <a:r>
+              <a:t>• Partial — some conditions unmet → defer to surrogate</a:t>
+            </a:r>
+          </a:p>
+          <a:p>
+            <a:r>
+              <a:t>• No coverage — directive silent; do NOT presume</a:t>
+            </a:r>
+          </a:p>
+          <a:p>
+            <a:r>
+              <a:t>• Vague — surface imprecise language (“no heroic measures”)</a:t>
+            </a:r>
+          </a:p>
+          <a:p/>
+          <a:p>
+            <a:r>
+              <a:t>Safety feature: uncertainty is visible. A checkbox or overconfident LLM cannot say “I don’t know.”</a:t>
+            </a:r>
+          </a:p>
+          <a:p/>
+          <a:p>
+            <a:r>
+              <a:t>Transition → end-to-end pipeline.</a:t>
+            </a:r>
           </a:p>
         </p:txBody>
       </p:sp>
@@ -3098,20 +3198,27 @@
           </a:bodyPr>
           <a:lstStyle/>
           <a:p>
-            <a:pPr indent="0" lvl="0" marL="0" rtl="0" algn="l">
-              <a:spcBef>
-                <a:spcPts val="0"/>
-              </a:spcBef>
-              <a:spcAft>
-                <a:spcPts val="0"/>
-              </a:spcAft>
-              <a:buNone/>
-            </a:pPr>
-            <a:r>
-              <a:rPr lang="en-US"/>
-              <a:t>Presenter note: Slide 7 summarizes the ADO final report and is designed for a concise project presentation.</a:t>
-            </a:r>
-            <a:endParaRPr/>
+            <a:r>
+              <a:t>[~45s] LLMs ONLY at the boundary. Closed-world extraction → validated JSON → OWL individuals → deterministic scenario reasoner → four-category output + code status/POLST.</a:t>
+            </a:r>
+          </a:p>
+          <a:p/>
+          <a:p>
+            <a:r>
+              <a:t>Closed-world rule: extract only what the patient stated; out-of-scope text (nutrition, antibiotics) must NOT map to nearest class—that enables trustworthy “no coverage.”</a:t>
+            </a:r>
+          </a:p>
+          <a:p/>
+          <a:p>
+            <a:r>
+              <a:t>Tagline: ontology WITH LLMs, not versus LLMs.</a:t>
+            </a:r>
+          </a:p>
+          <a:p/>
+          <a:p>
+            <a:r>
+              <a:t>Transition → how we evaluated.</a:t>
+            </a:r>
           </a:p>
         </p:txBody>
       </p:sp>
@@ -3256,20 +3363,40 @@
           </a:bodyPr>
           <a:lstStyle/>
           <a:p>
-            <a:pPr indent="0" lvl="0" marL="0" rtl="0" algn="l">
-              <a:spcBef>
-                <a:spcPts val="0"/>
-              </a:spcBef>
-              <a:spcAft>
-                <a:spcPts val="0"/>
-              </a:spcAft>
-              <a:buNone/>
-            </a:pPr>
-            <a:r>
-              <a:rPr lang="en-US"/>
-              <a:t>Presenter note: Slide 8 summarizes the ADO final report and is designed for a concise project presentation.</a:t>
-            </a:r>
-            <a:endParaRPr/>
+            <a:r>
+              <a:t>[~50s] Five evaluation strands:</a:t>
+            </a:r>
+          </a:p>
+          <a:p>
+            <a:r>
+              <a:t>1) Pipeline: example patient populates end-to-end (9 prefs, 50 individuals).</a:t>
+            </a:r>
+          </a:p>
+          <a:p>
+            <a:r>
+              <a:t>2) 16 vignettes, all decision points &amp; output types; gold = team-adjudicated expected answers.</a:t>
+            </a:r>
+          </a:p>
+          <a:p>
+            <a:r>
+              <a:t>3) Ablation (post-hoc sensitivity): re-score vignettes ignoring activation conditions → 12/16 (75%) vs 16/16 (100%). All four errors are conditional/partial cases—shows condition modeling matters. (Document as sensitivity analysis, not a separate SWRL experiment.)</a:t>
+            </a:r>
+          </a:p>
+          <a:p>
+            <a:r>
+              <a:t>4) LLM extraction: 12 real-template statements + 2 out-of-scope tests.</a:t>
+            </a:r>
+          </a:p>
+          <a:p>
+            <a:r>
+              <a:t>5) Track 3: 12 profiles → code status/POLST vs POLST semantics gold + Magnus expert review.</a:t>
+            </a:r>
+          </a:p>
+          <a:p/>
+          <a:p>
+            <a:r>
+              <a:t>Caveat if asked: gold is team-authored but grounded in real templates and independent POLST definitions; blind rater sheets in repo.</a:t>
+            </a:r>
           </a:p>
         </p:txBody>
       </p:sp>
@@ -3414,20 +3541,39 @@
           </a:bodyPr>
           <a:lstStyle/>
           <a:p>
-            <a:pPr indent="0" lvl="0" marL="0" rtl="0" algn="l">
-              <a:spcBef>
-                <a:spcPts val="0"/>
-              </a:spcBef>
-              <a:spcAft>
-                <a:spcPts val="0"/>
-              </a:spcAft>
-              <a:buNone/>
-            </a:pPr>
-            <a:r>
-              <a:rPr lang="en-US"/>
-              <a:t>Presenter note: Slide 9 summarizes the ADO final report and is designed for a concise project presentation.</a:t>
-            </a:r>
-            <a:endParaRPr/>
+            <a:r>
+              <a:t>[~60s — FLAGSHIP] Track 1: 16/16 decision AND match-type accuracy on vignettes.</a:t>
+            </a:r>
+          </a:p>
+          <a:p/>
+          <a:p>
+            <a:r>
+              <a:t>Track 2: Precision 0.94, recall 1.00, F1 0.97; negation/type/conditionality 15/15; ZERO hallucinations on out-of-scope nutrition &amp; antibiotics.</a:t>
+            </a:r>
+          </a:p>
+          <a:p/>
+          <a:p>
+            <a:r>
+              <a:t>Track 3: 12 real template profiles → 35/36 field agreement (97%): code status 12/12, POLST A 12/12, POLST B 11/12, exact profile 11/12; κ = 1.00 / 1.00 / 0.88.</a:t>
+            </a:r>
+          </a:p>
+          <a:p/>
+          <a:p>
+            <a:r>
+              <a:t>Ablation: ignoring conditions → 75% (4 false-confident errors on conditional vignettes).</a:t>
+            </a:r>
+          </a:p>
+          <a:p/>
+          <a:p>
+            <a:r>
+              <a:t>If time: P9 vs P10 same directive flips DNR↔Full code; P5 “miss” is principled (Not specified vs presuming Full Treatment).</a:t>
+            </a:r>
+          </a:p>
+          <a:p/>
+          <a:p>
+            <a:r>
+              <a:t>Transition → concrete if/then example.</a:t>
+            </a:r>
           </a:p>
         </p:txBody>
       </p:sp>
@@ -19221,41 +19367,10 @@
           </a:bodyPr>
           <a:lstStyle/>
           <a:p>
-            <a:pPr indent="0" lvl="0" marL="0" marR="0" rtl="0" algn="ctr">
-              <a:spcBef>
-                <a:spcPts val="0"/>
-              </a:spcBef>
-              <a:spcAft>
-                <a:spcPts val="0"/>
-              </a:spcAft>
-              <a:buClr>
-                <a:srgbClr val="68518A"/>
-              </a:buClr>
-              <a:buSzPts val="2900"/>
-              <a:buFont typeface="Arial"/>
-              <a:buNone/>
-            </a:pPr>
-            <a:r>
-              <a:rPr b="1" i="0" lang="en-US" sz="2900" u="none" cap="none" strike="noStrike">
-                <a:solidFill>
-                  <a:srgbClr val="68518A"/>
-                </a:solidFill>
-                <a:latin typeface="Arial"/>
-                <a:ea typeface="Arial"/>
-                <a:cs typeface="Arial"/>
-                <a:sym typeface="Arial"/>
-              </a:rPr>
-              <a:t>κ=1.00</a:t>
-            </a:r>
-            <a:endParaRPr b="0" i="0" sz="2900" u="none" cap="none" strike="noStrike">
-              <a:solidFill>
-                <a:schemeClr val="dk1"/>
-              </a:solidFill>
-              <a:latin typeface="Arial"/>
-              <a:ea typeface="Arial"/>
-              <a:cs typeface="Arial"/>
-              <a:sym typeface="Arial"/>
-            </a:endParaRPr>
+            <a:r>
+              <a:rPr sz="1400"/>
+              <a:t>κ=1.00 / 1.00 / 0.88</a:t>
+            </a:r>
           </a:p>
         </p:txBody>
       </p:sp>
@@ -19284,41 +19399,9 @@
           </a:bodyPr>
           <a:lstStyle/>
           <a:p>
-            <a:pPr indent="0" lvl="0" marL="0" marR="0" rtl="0" algn="ctr">
-              <a:spcBef>
-                <a:spcPts val="0"/>
-              </a:spcBef>
-              <a:spcAft>
-                <a:spcPts val="0"/>
-              </a:spcAft>
-              <a:buClr>
-                <a:srgbClr val="59656F"/>
-              </a:buClr>
-              <a:buSzPts val="1150"/>
-              <a:buFont typeface="Arial"/>
-              <a:buNone/>
-            </a:pPr>
-            <a:r>
-              <a:rPr b="0" i="0" lang="en-US" sz="1150" u="none" cap="none" strike="noStrike">
-                <a:solidFill>
-                  <a:srgbClr val="59656F"/>
-                </a:solidFill>
-                <a:latin typeface="Arial"/>
-                <a:ea typeface="Arial"/>
-                <a:cs typeface="Arial"/>
-                <a:sym typeface="Arial"/>
-              </a:rPr>
-              <a:t>code status + POLST A</a:t>
-            </a:r>
-            <a:endParaRPr b="0" i="0" sz="1150" u="none" cap="none" strike="noStrike">
-              <a:solidFill>
-                <a:schemeClr val="dk1"/>
-              </a:solidFill>
-              <a:latin typeface="Arial"/>
-              <a:ea typeface="Arial"/>
-              <a:cs typeface="Arial"/>
-              <a:sym typeface="Arial"/>
-            </a:endParaRPr>
+            <a:r>
+              <a:t>code / POLST A / POLST B</a:t>
+            </a:r>
           </a:p>
         </p:txBody>
       </p:sp>
@@ -19760,41 +19843,9 @@
           </a:bodyPr>
           <a:lstStyle/>
           <a:p>
-            <a:pPr indent="0" lvl="0" marL="0" marR="0" rtl="0" algn="l">
-              <a:spcBef>
-                <a:spcPts val="0"/>
-              </a:spcBef>
-              <a:spcAft>
-                <a:spcPts val="0"/>
-              </a:spcAft>
-              <a:buClr>
-                <a:srgbClr val="59656F"/>
-              </a:buClr>
-              <a:buSzPts val="1500"/>
-              <a:buFont typeface="Arial"/>
-              <a:buNone/>
-            </a:pPr>
-            <a:r>
-              <a:rPr b="0" i="0" lang="en-US" sz="1500" u="none" cap="none" strike="noStrike">
-                <a:solidFill>
-                  <a:srgbClr val="59656F"/>
-                </a:solidFill>
-                <a:latin typeface="Arial"/>
-                <a:ea typeface="Arial"/>
-                <a:cs typeface="Arial"/>
-                <a:sym typeface="Arial"/>
-              </a:rPr>
-              <a:t>Ignoring activation conditions produced false-confident errors on the four conditional cases.</a:t>
-            </a:r>
-            <a:endParaRPr b="0" i="0" sz="1500" u="none" cap="none" strike="noStrike">
-              <a:solidFill>
-                <a:schemeClr val="dk1"/>
-              </a:solidFill>
-              <a:latin typeface="Arial"/>
-              <a:ea typeface="Arial"/>
-              <a:cs typeface="Arial"/>
-              <a:sym typeface="Arial"/>
-            </a:endParaRPr>
+            <a:r>
+              <a:t>Post-hoc ablation: ignore activation conditions on the same 16 vignettes → 12/16 (75%). All four errors are conditional/partial cases.</a:t>
+            </a:r>
           </a:p>
         </p:txBody>
       </p:sp>
@@ -19868,6 +19919,37 @@
               <a:cs typeface="Arial"/>
               <a:sym typeface="Arial"/>
             </a:endParaRPr>
+          </a:p>
+        </p:txBody>
+      </p:sp>
+      <p:sp>
+        <p:nvSpPr>
+          <p:cNvPr id="221" name="TextBox 220"/>
+          <p:cNvSpPr txBox="1"/>
+          <p:nvPr/>
+        </p:nvSpPr>
+        <p:spPr>
+          <a:xfrm>
+            <a:off x="411480" y="5989320"/>
+            <a:ext cx="11338560" cy="502920"/>
+          </a:xfrm>
+          <a:prstGeom prst="rect">
+            <a:avLst/>
+          </a:prstGeom>
+          <a:noFill/>
+        </p:spPr>
+        <p:txBody>
+          <a:bodyPr wrap="square">
+            <a:spAutoFit/>
+          </a:bodyPr>
+          <a:lstStyle/>
+          <a:p>
+            <a:pPr>
+              <a:defRPr sz="1100"/>
+            </a:pPr>
+            <a:r>
+              <a:t>Also: extraction P/R = 0.94 / 1.00 • 0 out-of-scope hallucinations • 11/12 profiles exact match on all three bedside fields</a:t>
+            </a:r>
           </a:p>
         </p:txBody>
       </p:sp>

</xml_diff>

<commit_message>
Add speaker notes and align presentation metrics with evaluation results (#3)
- Embed per-slide speaker notes (~8 min) in ADO_powerpoint_presentation.pptx
- Add docs/Presentation_Speaker_Notes.md with full script, split, and Q&A prep
- Update slide 9 with Track 2/3 footnote metrics and clarified ablation wording
- Add script to regenerate notes from source

Co-authored-by: Cursor Agent <cursoragent@cursor.com>
Co-authored-by: patrickwalsh26 <patrickwalsh26@users.noreply.github.com>
</commit_message>
<xml_diff>
--- a/ADO_powerpoint_presentation.pptx
+++ b/ADO_powerpoint_presentation.pptx
@@ -1518,20 +1518,21 @@
           </a:bodyPr>
           <a:lstStyle/>
           <a:p>
-            <a:pPr indent="0" lvl="0" marL="0" rtl="0" algn="l">
-              <a:spcBef>
-                <a:spcPts val="0"/>
-              </a:spcBef>
-              <a:spcAft>
-                <a:spcPts val="0"/>
-              </a:spcAft>
-              <a:buNone/>
-            </a:pPr>
-            <a:r>
-              <a:rPr lang="en-US"/>
-              <a:t>Presenter note: Slide 1 summarizes the ADO final report and is designed for a concise project presentation.</a:t>
-            </a:r>
-            <a:endParaRPr/>
+            <a:r>
+              <a:t>[~30s] Good morning. Patrick Walsh and Darren Chan, Stanford BMDS 210 / CS 270.</a:t>
+            </a:r>
+          </a:p>
+          <a:p/>
+          <a:p>
+            <a:r>
+              <a:t>Hook: ADO is a computable OWL 2 representation of end-of-life preferences in advanced heart failure—not a legal advance directive, but a decision-support layer that helps clinicians reason over what patients said and pre-populate ACP documentation.</a:t>
+            </a:r>
+          </a:p>
+          <a:p/>
+          <a:p>
+            <a:r>
+              <a:t>Transition → why the bedside workflow breaks down.</a:t>
+            </a:r>
           </a:p>
         </p:txBody>
       </p:sp>
@@ -1676,20 +1677,31 @@
           </a:bodyPr>
           <a:lstStyle/>
           <a:p>
-            <a:pPr indent="0" lvl="0" marL="0" rtl="0" algn="l">
-              <a:spcBef>
-                <a:spcPts val="0"/>
-              </a:spcBef>
-              <a:spcAft>
-                <a:spcPts val="0"/>
-              </a:spcAft>
-              <a:buNone/>
-            </a:pPr>
-            <a:r>
-              <a:rPr lang="en-US"/>
-              <a:t>Presenter note: Slide 10 summarizes the ADO final report and is designed for a concise project presentation.</a:t>
-            </a:r>
-            <a:endParaRPr/>
+            <a:r>
+              <a:t>[~50s] Same directive, two scenarios:</a:t>
+            </a:r>
+          </a:p>
+          <a:p>
+            <a:r>
+              <a:t>A: NYHA IV + no reversible cause → DNR, clear.</a:t>
+            </a:r>
+          </a:p>
+          <a:p>
+            <a:r>
+              <a:t>B: NYHA III + reversible cause → Full code, partial.</a:t>
+            </a:r>
+          </a:p>
+          <a:p/>
+          <a:p>
+            <a:r>
+              <a:t>Flat POLST/checkbox must over-apply or discard the condition. ADO preserves if/then and flags when it applies.</a:t>
+            </a:r>
+          </a:p>
+          <a:p/>
+          <a:p>
+            <a:r>
+              <a:t>Transition → where this lives clinically.</a:t>
+            </a:r>
           </a:p>
         </p:txBody>
       </p:sp>
@@ -1834,20 +1846,33 @@
           </a:bodyPr>
           <a:lstStyle/>
           <a:p>
-            <a:pPr indent="0" lvl="0" marL="0" rtl="0" algn="l">
-              <a:spcBef>
-                <a:spcPts val="0"/>
-              </a:spcBef>
-              <a:spcAft>
-                <a:spcPts val="0"/>
-              </a:spcAft>
-              <a:buNone/>
-            </a:pPr>
-            <a:r>
-              <a:rPr lang="en-US"/>
-              <a:t>Presenter note: Slide 11 summarizes the ADO final report and is designed for a concise project presentation.</a:t>
-            </a:r>
-            <a:endParaRPr/>
+            <a:r>
+              <a:t>[~40s] Dr. David Magnus (Stanford Biomedical Ethics): “You can’t think of these as AHCDs… more like a progress note.”</a:t>
+            </a:r>
+          </a:p>
+          <a:p/>
+          <a:p>
+            <a:r>
+              <a:t>Near-term product: pre-populate Epic-style ACP note → provider conversation can clarify/override → final ACP + POLST/code status.</a:t>
+            </a:r>
+          </a:p>
+          <a:p/>
+          <a:p>
+            <a:r>
+              <a:t>Not a legal directive; complements POLST and code status.</a:t>
+            </a:r>
+          </a:p>
+          <a:p/>
+          <a:p>
+            <a:r>
+              <a:t>If asked: next modeling gap is WHO decides (surrogate override), not just WHAT intervention.</a:t>
+            </a:r>
+          </a:p>
+          <a:p/>
+          <a:p>
+            <a:r>
+              <a:t>Transition → limitations.</a:t>
+            </a:r>
           </a:p>
         </p:txBody>
       </p:sp>
@@ -1992,20 +2017,40 @@
           </a:bodyPr>
           <a:lstStyle/>
           <a:p>
-            <a:pPr indent="0" lvl="0" marL="0" rtl="0" algn="l">
-              <a:spcBef>
-                <a:spcPts val="0"/>
-              </a:spcBef>
-              <a:spcAft>
-                <a:spcPts val="0"/>
-              </a:spcAft>
-              <a:buNone/>
-            </a:pPr>
-            <a:r>
-              <a:rPr lang="en-US"/>
-              <a:t>Presenter note: Slide 12 summarizes the ADO final report and is designed for a concise project presentation.</a:t>
-            </a:r>
-            <a:endParaRPr/>
+            <a:r>
+              <a:t>[~40s] Honest limits:</a:t>
+            </a:r>
+          </a:p>
+          <a:p>
+            <a:r>
+              <a:t>• No legal force</a:t>
+            </a:r>
+          </a:p>
+          <a:p>
+            <a:r>
+              <a:t>• One-dimensional (what, not who decides) — top priority extension</a:t>
+            </a:r>
+          </a:p>
+          <a:p>
+            <a:r>
+              <a:t>• Coverage gaps: artificial nutrition, antibiotics, comfort care</a:t>
+            </a:r>
+          </a:p>
+          <a:p>
+            <a:r>
+              <a:t>• Temporal: numeric hour bounds, not full temporal logic</a:t>
+            </a:r>
+          </a:p>
+          <a:p>
+            <a:r>
+              <a:t>• Gold standards team-authored; real EHR validation (MIMIC-IV) future</a:t>
+            </a:r>
+          </a:p>
+          <a:p/>
+          <a:p>
+            <a:r>
+              <a:t>Principle: surface uncertainty; don’t replace clinicians/surrogates.</a:t>
+            </a:r>
           </a:p>
         </p:txBody>
       </p:sp>
@@ -2150,20 +2195,26 @@
           </a:bodyPr>
           <a:lstStyle/>
           <a:p>
-            <a:pPr indent="0" lvl="0" marL="0" rtl="0" algn="l">
-              <a:spcBef>
-                <a:spcPts val="0"/>
-              </a:spcBef>
-              <a:spcAft>
-                <a:spcPts val="0"/>
-              </a:spcAft>
-              <a:buNone/>
-            </a:pPr>
-            <a:r>
-              <a:rPr lang="en-US"/>
-              <a:t>Presenter note: Slide 13 summarizes the ADO final report and is designed for a concise project presentation.</a:t>
-            </a:r>
-            <a:endParaRPr/>
+            <a:r>
+              <a:t>[~30s] Four takeaways on slide—read them, don’t rush.</a:t>
+            </a:r>
+          </a:p>
+          <a:p/>
+          <a:p>
+            <a:r>
+              <a:t>Close: Questions welcome.</a:t>
+            </a:r>
+          </a:p>
+          <a:p>
+            <a:r>
+              <a:t>Repo: https://github.com/patrickwalsh26/bmds210-AD_Ontology</a:t>
+            </a:r>
+          </a:p>
+          <a:p/>
+          <a:p>
+            <a:r>
+              <a:t>Q&amp;A prep: legal AD? No. Why not LLM only? Over-confident, not auditable. Weakest point? Team gold + P5 principled divergence.</a:t>
+            </a:r>
           </a:p>
         </p:txBody>
       </p:sp>
@@ -2308,20 +2359,33 @@
           </a:bodyPr>
           <a:lstStyle/>
           <a:p>
-            <a:pPr indent="0" lvl="0" marL="0" rtl="0" algn="l">
-              <a:spcBef>
-                <a:spcPts val="0"/>
-              </a:spcBef>
-              <a:spcAft>
-                <a:spcPts val="0"/>
-              </a:spcAft>
-              <a:buNone/>
-            </a:pPr>
-            <a:r>
-              <a:rPr lang="en-US"/>
-              <a:t>Presenter note: Slide 2 summarizes the ADO final report and is designed for a concise project presentation.</a:t>
-            </a:r>
-            <a:endParaRPr/>
+            <a:r>
+              <a:t>[~45s] Three instruments, three jobs: advance directive (values/wishes), POLST (portable orders), code status (what we act on at 2 a.m.).</a:t>
+            </a:r>
+          </a:p>
+          <a:p/>
+          <a:p>
+            <a:r>
+              <a:t>The loss is in the middle—conditional wishes become coarse checkboxes or bedside orders.</a:t>
+            </a:r>
+          </a:p>
+          <a:p/>
+          <a:p>
+            <a:r>
+              <a:t>Important reframe (Magnus): the problem is NOT mainly “unreadable free text.” CA and UC forms are mostly checkboxes. They are low-resolution and disease-blind.</a:t>
+            </a:r>
+          </a:p>
+          <a:p/>
+          <a:p>
+            <a:r>
+              <a:t>Point to the ventilator example: temporary-if-reversible vs never-indefinitely cannot fit a yes/no box.</a:t>
+            </a:r>
+          </a:p>
+          <a:p/>
+          <a:p>
+            <a:r>
+              <a:t>Transition → why we scoped to advanced HF.</a:t>
+            </a:r>
           </a:p>
         </p:txBody>
       </p:sp>
@@ -2466,20 +2530,27 @@
           </a:bodyPr>
           <a:lstStyle/>
           <a:p>
-            <a:pPr indent="0" lvl="0" marL="0" rtl="0" algn="l">
-              <a:spcBef>
-                <a:spcPts val="0"/>
-              </a:spcBef>
-              <a:spcAft>
-                <a:spcPts val="0"/>
-              </a:spcAft>
-              <a:buNone/>
-            </a:pPr>
-            <a:r>
-              <a:rPr lang="en-US"/>
-              <a:t>Presenter note: Slide 3 summarizes the ADO final report and is designed for a concise project presentation.</a:t>
-            </a:r>
-            <a:endParaRPr/>
+            <a:r>
+              <a:t>[~40s] HF is unpredictable, device-dependent, and patients revisit the ED/ICU—preference interpretation is time-pressured and repeated.</a:t>
+            </a:r>
+          </a:p>
+          <a:p/>
+          <a:p>
+            <a:r>
+              <a:t>Five decision points on slide: CPR, ventilation, devices, vasopressors/inotropes, dialysis.</a:t>
+            </a:r>
+          </a:p>
+          <a:p/>
+          <a:p>
+            <a:r>
+              <a:t>~200K HF patients have ICDs; generic ADs rarely mention ICD/LVAD/inotropes—that gap motivates our scope.</a:t>
+            </a:r>
+          </a:p>
+          <a:p/>
+          <a:p>
+            <a:r>
+              <a:t>Transition → how we represent a preference computationally.</a:t>
+            </a:r>
           </a:p>
         </p:txBody>
       </p:sp>
@@ -2624,20 +2695,27 @@
           </a:bodyPr>
           <a:lstStyle/>
           <a:p>
-            <a:pPr indent="0" lvl="0" marL="0" rtl="0" algn="l">
-              <a:spcBef>
-                <a:spcPts val="0"/>
-              </a:spcBef>
-              <a:spcAft>
-                <a:spcPts val="0"/>
-              </a:spcAft>
-              <a:buNone/>
-            </a:pPr>
-            <a:r>
-              <a:rPr lang="en-US"/>
-              <a:t>Presenter note: Slide 4 summarizes the ADO final report and is designed for a concise project presentation.</a:t>
-            </a:r>
-            <a:endParaRPr/>
+            <a:r>
+              <a:t>[~45s] Core unit: PreferenceStatement = intervention + activation conditions + strength + negation + verbatim originalText.</a:t>
+            </a:r>
+          </a:p>
+          <a:p/>
+          <a:p>
+            <a:r>
+              <a:t>Walk the vasopressor example: 72h “no improvement” becomes a structured activation condition the reasoner can test.</a:t>
+            </a:r>
+          </a:p>
+          <a:p/>
+          <a:p>
+            <a:r>
+              <a:t>Why verbatim text? Auditable—clinicians see patient language behind the inference.</a:t>
+            </a:r>
+          </a:p>
+          <a:p/>
+          <a:p>
+            <a:r>
+              <a:t>Transition → ontology size and granularity.</a:t>
+            </a:r>
           </a:p>
         </p:txBody>
       </p:sp>
@@ -2782,20 +2860,21 @@
           </a:bodyPr>
           <a:lstStyle/>
           <a:p>
-            <a:pPr indent="0" lvl="0" marL="0" rtl="0" algn="l">
-              <a:spcBef>
-                <a:spcPts val="0"/>
-              </a:spcBef>
-              <a:spcAft>
-                <a:spcPts val="0"/>
-              </a:spcAft>
-              <a:buNone/>
-            </a:pPr>
-            <a:r>
-              <a:rPr lang="en-US"/>
-              <a:t>Presenter note: Slide 5 summarizes the ADO final report and is designed for a concise project presentation.</a:t>
-            </a:r>
-            <a:endParaRPr/>
+            <a:r>
+              <a:t>[~40s] 67 classes, 22 properties, 21 intervention subclasses—finer than any single template in our 50-form inventory (e.g., six ventilation types vs one checkbox).</a:t>
+            </a:r>
+          </a:p>
+          <a:p/>
+          <a:p>
+            <a:r>
+              <a:t>SNOMED CT grounding where possible for interoperability.</a:t>
+            </a:r>
+          </a:p>
+          <a:p/>
+          <a:p>
+            <a:r>
+              <a:t>Transition → we don’t force binary answers.</a:t>
+            </a:r>
           </a:p>
         </p:txBody>
       </p:sp>
@@ -2940,20 +3019,41 @@
           </a:bodyPr>
           <a:lstStyle/>
           <a:p>
-            <a:pPr indent="0" lvl="0" marL="0" rtl="0" algn="l">
-              <a:spcBef>
-                <a:spcPts val="0"/>
-              </a:spcBef>
-              <a:spcAft>
-                <a:spcPts val="0"/>
-              </a:spcAft>
-              <a:buNone/>
-            </a:pPr>
-            <a:r>
-              <a:rPr lang="en-US"/>
-              <a:t>Presenter note: Slide 6 summarizes the ADO final report and is designed for a concise project presentation.</a:t>
-            </a:r>
-            <a:endParaRPr/>
+            <a:r>
+              <a:t>[~45s] Four honest outputs:</a:t>
+            </a:r>
+          </a:p>
+          <a:p>
+            <a:r>
+              <a:t>• Clear — conditions met, unambiguous</a:t>
+            </a:r>
+          </a:p>
+          <a:p>
+            <a:r>
+              <a:t>• Partial — some conditions unmet → defer to surrogate</a:t>
+            </a:r>
+          </a:p>
+          <a:p>
+            <a:r>
+              <a:t>• No coverage — directive silent; do NOT presume</a:t>
+            </a:r>
+          </a:p>
+          <a:p>
+            <a:r>
+              <a:t>• Vague — surface imprecise language (“no heroic measures”)</a:t>
+            </a:r>
+          </a:p>
+          <a:p/>
+          <a:p>
+            <a:r>
+              <a:t>Safety feature: uncertainty is visible. A checkbox or overconfident LLM cannot say “I don’t know.”</a:t>
+            </a:r>
+          </a:p>
+          <a:p/>
+          <a:p>
+            <a:r>
+              <a:t>Transition → end-to-end pipeline.</a:t>
+            </a:r>
           </a:p>
         </p:txBody>
       </p:sp>
@@ -3098,20 +3198,27 @@
           </a:bodyPr>
           <a:lstStyle/>
           <a:p>
-            <a:pPr indent="0" lvl="0" marL="0" rtl="0" algn="l">
-              <a:spcBef>
-                <a:spcPts val="0"/>
-              </a:spcBef>
-              <a:spcAft>
-                <a:spcPts val="0"/>
-              </a:spcAft>
-              <a:buNone/>
-            </a:pPr>
-            <a:r>
-              <a:rPr lang="en-US"/>
-              <a:t>Presenter note: Slide 7 summarizes the ADO final report and is designed for a concise project presentation.</a:t>
-            </a:r>
-            <a:endParaRPr/>
+            <a:r>
+              <a:t>[~45s] LLMs ONLY at the boundary. Closed-world extraction → validated JSON → OWL individuals → deterministic scenario reasoner → four-category output + code status/POLST.</a:t>
+            </a:r>
+          </a:p>
+          <a:p/>
+          <a:p>
+            <a:r>
+              <a:t>Closed-world rule: extract only what the patient stated; out-of-scope text (nutrition, antibiotics) must NOT map to nearest class—that enables trustworthy “no coverage.”</a:t>
+            </a:r>
+          </a:p>
+          <a:p/>
+          <a:p>
+            <a:r>
+              <a:t>Tagline: ontology WITH LLMs, not versus LLMs.</a:t>
+            </a:r>
+          </a:p>
+          <a:p/>
+          <a:p>
+            <a:r>
+              <a:t>Transition → how we evaluated.</a:t>
+            </a:r>
           </a:p>
         </p:txBody>
       </p:sp>
@@ -3256,20 +3363,40 @@
           </a:bodyPr>
           <a:lstStyle/>
           <a:p>
-            <a:pPr indent="0" lvl="0" marL="0" rtl="0" algn="l">
-              <a:spcBef>
-                <a:spcPts val="0"/>
-              </a:spcBef>
-              <a:spcAft>
-                <a:spcPts val="0"/>
-              </a:spcAft>
-              <a:buNone/>
-            </a:pPr>
-            <a:r>
-              <a:rPr lang="en-US"/>
-              <a:t>Presenter note: Slide 8 summarizes the ADO final report and is designed for a concise project presentation.</a:t>
-            </a:r>
-            <a:endParaRPr/>
+            <a:r>
+              <a:t>[~50s] Five evaluation strands:</a:t>
+            </a:r>
+          </a:p>
+          <a:p>
+            <a:r>
+              <a:t>1) Pipeline: example patient populates end-to-end (9 prefs, 50 individuals).</a:t>
+            </a:r>
+          </a:p>
+          <a:p>
+            <a:r>
+              <a:t>2) 16 vignettes, all decision points &amp; output types; gold = team-adjudicated expected answers.</a:t>
+            </a:r>
+          </a:p>
+          <a:p>
+            <a:r>
+              <a:t>3) Ablation (post-hoc sensitivity): re-score vignettes ignoring activation conditions → 12/16 (75%) vs 16/16 (100%). All four errors are conditional/partial cases—shows condition modeling matters. (Document as sensitivity analysis, not a separate SWRL experiment.)</a:t>
+            </a:r>
+          </a:p>
+          <a:p>
+            <a:r>
+              <a:t>4) LLM extraction: 12 real-template statements + 2 out-of-scope tests.</a:t>
+            </a:r>
+          </a:p>
+          <a:p>
+            <a:r>
+              <a:t>5) Track 3: 12 profiles → code status/POLST vs POLST semantics gold + Magnus expert review.</a:t>
+            </a:r>
+          </a:p>
+          <a:p/>
+          <a:p>
+            <a:r>
+              <a:t>Caveat if asked: gold is team-authored but grounded in real templates and independent POLST definitions; blind rater sheets in repo.</a:t>
+            </a:r>
           </a:p>
         </p:txBody>
       </p:sp>
@@ -3414,20 +3541,39 @@
           </a:bodyPr>
           <a:lstStyle/>
           <a:p>
-            <a:pPr indent="0" lvl="0" marL="0" rtl="0" algn="l">
-              <a:spcBef>
-                <a:spcPts val="0"/>
-              </a:spcBef>
-              <a:spcAft>
-                <a:spcPts val="0"/>
-              </a:spcAft>
-              <a:buNone/>
-            </a:pPr>
-            <a:r>
-              <a:rPr lang="en-US"/>
-              <a:t>Presenter note: Slide 9 summarizes the ADO final report and is designed for a concise project presentation.</a:t>
-            </a:r>
-            <a:endParaRPr/>
+            <a:r>
+              <a:t>[~60s — FLAGSHIP] Track 1: 16/16 decision AND match-type accuracy on vignettes.</a:t>
+            </a:r>
+          </a:p>
+          <a:p/>
+          <a:p>
+            <a:r>
+              <a:t>Track 2: Precision 0.94, recall 1.00, F1 0.97; negation/type/conditionality 15/15; ZERO hallucinations on out-of-scope nutrition &amp; antibiotics.</a:t>
+            </a:r>
+          </a:p>
+          <a:p/>
+          <a:p>
+            <a:r>
+              <a:t>Track 3: 12 real template profiles → 35/36 field agreement (97%): code status 12/12, POLST A 12/12, POLST B 11/12, exact profile 11/12; κ = 1.00 / 1.00 / 0.88.</a:t>
+            </a:r>
+          </a:p>
+          <a:p/>
+          <a:p>
+            <a:r>
+              <a:t>Ablation: ignoring conditions → 75% (4 false-confident errors on conditional vignettes).</a:t>
+            </a:r>
+          </a:p>
+          <a:p/>
+          <a:p>
+            <a:r>
+              <a:t>If time: P9 vs P10 same directive flips DNR↔Full code; P5 “miss” is principled (Not specified vs presuming Full Treatment).</a:t>
+            </a:r>
+          </a:p>
+          <a:p/>
+          <a:p>
+            <a:r>
+              <a:t>Transition → concrete if/then example.</a:t>
+            </a:r>
           </a:p>
         </p:txBody>
       </p:sp>
@@ -19221,41 +19367,10 @@
           </a:bodyPr>
           <a:lstStyle/>
           <a:p>
-            <a:pPr indent="0" lvl="0" marL="0" marR="0" rtl="0" algn="ctr">
-              <a:spcBef>
-                <a:spcPts val="0"/>
-              </a:spcBef>
-              <a:spcAft>
-                <a:spcPts val="0"/>
-              </a:spcAft>
-              <a:buClr>
-                <a:srgbClr val="68518A"/>
-              </a:buClr>
-              <a:buSzPts val="2900"/>
-              <a:buFont typeface="Arial"/>
-              <a:buNone/>
-            </a:pPr>
-            <a:r>
-              <a:rPr b="1" i="0" lang="en-US" sz="2900" u="none" cap="none" strike="noStrike">
-                <a:solidFill>
-                  <a:srgbClr val="68518A"/>
-                </a:solidFill>
-                <a:latin typeface="Arial"/>
-                <a:ea typeface="Arial"/>
-                <a:cs typeface="Arial"/>
-                <a:sym typeface="Arial"/>
-              </a:rPr>
-              <a:t>κ=1.00</a:t>
-            </a:r>
-            <a:endParaRPr b="0" i="0" sz="2900" u="none" cap="none" strike="noStrike">
-              <a:solidFill>
-                <a:schemeClr val="dk1"/>
-              </a:solidFill>
-              <a:latin typeface="Arial"/>
-              <a:ea typeface="Arial"/>
-              <a:cs typeface="Arial"/>
-              <a:sym typeface="Arial"/>
-            </a:endParaRPr>
+            <a:r>
+              <a:rPr sz="1400"/>
+              <a:t>κ=1.00 / 1.00 / 0.88</a:t>
+            </a:r>
           </a:p>
         </p:txBody>
       </p:sp>
@@ -19284,41 +19399,9 @@
           </a:bodyPr>
           <a:lstStyle/>
           <a:p>
-            <a:pPr indent="0" lvl="0" marL="0" marR="0" rtl="0" algn="ctr">
-              <a:spcBef>
-                <a:spcPts val="0"/>
-              </a:spcBef>
-              <a:spcAft>
-                <a:spcPts val="0"/>
-              </a:spcAft>
-              <a:buClr>
-                <a:srgbClr val="59656F"/>
-              </a:buClr>
-              <a:buSzPts val="1150"/>
-              <a:buFont typeface="Arial"/>
-              <a:buNone/>
-            </a:pPr>
-            <a:r>
-              <a:rPr b="0" i="0" lang="en-US" sz="1150" u="none" cap="none" strike="noStrike">
-                <a:solidFill>
-                  <a:srgbClr val="59656F"/>
-                </a:solidFill>
-                <a:latin typeface="Arial"/>
-                <a:ea typeface="Arial"/>
-                <a:cs typeface="Arial"/>
-                <a:sym typeface="Arial"/>
-              </a:rPr>
-              <a:t>code status + POLST A</a:t>
-            </a:r>
-            <a:endParaRPr b="0" i="0" sz="1150" u="none" cap="none" strike="noStrike">
-              <a:solidFill>
-                <a:schemeClr val="dk1"/>
-              </a:solidFill>
-              <a:latin typeface="Arial"/>
-              <a:ea typeface="Arial"/>
-              <a:cs typeface="Arial"/>
-              <a:sym typeface="Arial"/>
-            </a:endParaRPr>
+            <a:r>
+              <a:t>code / POLST A / POLST B</a:t>
+            </a:r>
           </a:p>
         </p:txBody>
       </p:sp>
@@ -19760,41 +19843,9 @@
           </a:bodyPr>
           <a:lstStyle/>
           <a:p>
-            <a:pPr indent="0" lvl="0" marL="0" marR="0" rtl="0" algn="l">
-              <a:spcBef>
-                <a:spcPts val="0"/>
-              </a:spcBef>
-              <a:spcAft>
-                <a:spcPts val="0"/>
-              </a:spcAft>
-              <a:buClr>
-                <a:srgbClr val="59656F"/>
-              </a:buClr>
-              <a:buSzPts val="1500"/>
-              <a:buFont typeface="Arial"/>
-              <a:buNone/>
-            </a:pPr>
-            <a:r>
-              <a:rPr b="0" i="0" lang="en-US" sz="1500" u="none" cap="none" strike="noStrike">
-                <a:solidFill>
-                  <a:srgbClr val="59656F"/>
-                </a:solidFill>
-                <a:latin typeface="Arial"/>
-                <a:ea typeface="Arial"/>
-                <a:cs typeface="Arial"/>
-                <a:sym typeface="Arial"/>
-              </a:rPr>
-              <a:t>Ignoring activation conditions produced false-confident errors on the four conditional cases.</a:t>
-            </a:r>
-            <a:endParaRPr b="0" i="0" sz="1500" u="none" cap="none" strike="noStrike">
-              <a:solidFill>
-                <a:schemeClr val="dk1"/>
-              </a:solidFill>
-              <a:latin typeface="Arial"/>
-              <a:ea typeface="Arial"/>
-              <a:cs typeface="Arial"/>
-              <a:sym typeface="Arial"/>
-            </a:endParaRPr>
+            <a:r>
+              <a:t>Post-hoc ablation: ignore activation conditions on the same 16 vignettes → 12/16 (75%). All four errors are conditional/partial cases.</a:t>
+            </a:r>
           </a:p>
         </p:txBody>
       </p:sp>
@@ -19868,6 +19919,37 @@
               <a:cs typeface="Arial"/>
               <a:sym typeface="Arial"/>
             </a:endParaRPr>
+          </a:p>
+        </p:txBody>
+      </p:sp>
+      <p:sp>
+        <p:nvSpPr>
+          <p:cNvPr id="221" name="TextBox 220"/>
+          <p:cNvSpPr txBox="1"/>
+          <p:nvPr/>
+        </p:nvSpPr>
+        <p:spPr>
+          <a:xfrm>
+            <a:off x="411480" y="5989320"/>
+            <a:ext cx="11338560" cy="502920"/>
+          </a:xfrm>
+          <a:prstGeom prst="rect">
+            <a:avLst/>
+          </a:prstGeom>
+          <a:noFill/>
+        </p:spPr>
+        <p:txBody>
+          <a:bodyPr wrap="square">
+            <a:spAutoFit/>
+          </a:bodyPr>
+          <a:lstStyle/>
+          <a:p>
+            <a:pPr>
+              <a:defRPr sz="1100"/>
+            </a:pPr>
+            <a:r>
+              <a:t>Also: extraction P/R = 0.94 / 1.00 • 0 out-of-scope hallucinations • 11/12 profiles exact match on all three bedside fields</a:t>
+            </a:r>
           </a:p>
         </p:txBody>
       </p:sp>

</xml_diff>

<commit_message>
Cohesive narrative speaker notes, evaluation figures, and live demo guide
- Rewrite speaker notes around a four-act story arc with explicit transitions
- Generate six evaluation PNGs and embed charts on slides 8-10 plus a figures slide
- Add Live_Demo_Guide.md and build_presentation_assets.sh for class prep
- Document deck and demo in README

Co-authored-by: patrickwalsh26 <patrickwalsh26@users.noreply.github.com>
</commit_message>
<xml_diff>
--- a/ADO_powerpoint_presentation.pptx
+++ b/ADO_powerpoint_presentation.pptx
@@ -21,6 +21,7 @@
     <p:sldId id="266" r:id="rId15"/>
     <p:sldId id="267" r:id="rId16"/>
     <p:sldId id="268" r:id="rId17"/>
+    <p:sldId id="269" r:id="rId19"/>
   </p:sldIdLst>
   <p:sldSz cy="6858000" cx="12191675"/>
   <p:notesSz cx="6858000" cy="12191675"/>
@@ -1519,19 +1520,22 @@
           <a:lstStyle/>
           <a:p>
             <a:r>
-              <a:t>[~30s] Good morning. Patrick Walsh and Darren Chan, Stanford BMDS 210 / CS 270.</a:t>
-            </a:r>
-          </a:p>
-          <a:p/>
-          <a:p>
-            <a:r>
-              <a:t>Hook: ADO is a computable OWL 2 representation of end-of-life preferences in advanced heart failure—not a legal advance directive, but a decision-support layer that helps clinicians reason over what patients said and pre-populate ACP documentation.</a:t>
-            </a:r>
-          </a:p>
-          <a:p/>
-          <a:p>
-            <a:r>
-              <a:t>Transition → why the bedside workflow breaks down.</a:t>
+              <a:t>NARRATIVE: Act I opens — frame the talk.</a:t>
+            </a:r>
+          </a:p>
+          <a:p>
+            <a:r>
+              <a:t>SAY: Patrick Walsh &amp; Darren Chan. ADO = computable EOL preferences in advanced HF. Not a legal AD — decision support for ACP documentation.</a:t>
+            </a:r>
+          </a:p>
+          <a:p>
+            <a:r>
+              <a:t>TRANSITION: "Start where clinicians live—the 2 a.m. crisis."</a:t>
+            </a:r>
+          </a:p>
+          <a:p>
+            <a:r>
+              <a:t>[~25s]</a:t>
             </a:r>
           </a:p>
         </p:txBody>
@@ -1678,29 +1682,27 @@
           <a:lstStyle/>
           <a:p>
             <a:r>
-              <a:t>[~50s] Same directive, two scenarios:</a:t>
-            </a:r>
-          </a:p>
-          <a:p>
-            <a:r>
-              <a:t>A: NYHA IV + no reversible cause → DNR, clear.</a:t>
-            </a:r>
-          </a:p>
-          <a:p>
-            <a:r>
-              <a:t>B: NYHA III + reversible cause → Full code, partial.</a:t>
-            </a:r>
-          </a:p>
-          <a:p/>
-          <a:p>
-            <a:r>
-              <a:t>Flat POLST/checkbox must over-apply or discard the condition. ADO preserves if/then and flags when it applies.</a:t>
-            </a:r>
-          </a:p>
-          <a:p/>
-          <a:p>
-            <a:r>
-              <a:t>Transition → where this lives clinically.</a:t>
+              <a:t>NARRATIVE: Act III — clinical "aha."</a:t>
+            </a:r>
+          </a:p>
+          <a:p>
+            <a:r>
+              <a:t>SAY: Same directive, two scenarios → DNR vs Full code. Flat POLST can't carry if/then.</a:t>
+            </a:r>
+          </a:p>
+          <a:p>
+            <a:r>
+              <a:t>POINT AT: P9/P10 figure if on slide.</a:t>
+            </a:r>
+          </a:p>
+          <a:p>
+            <a:r>
+              <a:t>TRANSITION: "An ethicist placed this in workflow."</a:t>
+            </a:r>
+          </a:p>
+          <a:p>
+            <a:r>
+              <a:t>[~40s]</a:t>
             </a:r>
           </a:p>
         </p:txBody>
@@ -1847,31 +1849,22 @@
           <a:lstStyle/>
           <a:p>
             <a:r>
-              <a:t>[~40s] Dr. David Magnus (Stanford Biomedical Ethics): “You can’t think of these as AHCDs… more like a progress note.”</a:t>
-            </a:r>
-          </a:p>
-          <a:p/>
-          <a:p>
-            <a:r>
-              <a:t>Near-term product: pre-populate Epic-style ACP note → provider conversation can clarify/override → final ACP + POLST/code status.</a:t>
-            </a:r>
-          </a:p>
-          <a:p/>
-          <a:p>
-            <a:r>
-              <a:t>Not a legal directive; complements POLST and code status.</a:t>
-            </a:r>
-          </a:p>
-          <a:p/>
-          <a:p>
-            <a:r>
-              <a:t>If asked: next modeling gap is WHO decides (surrogate override), not just WHAT intervention.</a:t>
-            </a:r>
-          </a:p>
-          <a:p/>
-          <a:p>
-            <a:r>
-              <a:t>Transition → limitations.</a:t>
+              <a:t>NARRATIVE: Act IV — Magnus reframe.</a:t>
+            </a:r>
+          </a:p>
+          <a:p>
+            <a:r>
+              <a:t>SAY: Not a signed AHCD — ACP progress note. Directive → ADO → ACP pre-pop → conversation → POLST/code status.</a:t>
+            </a:r>
+          </a:p>
+          <a:p>
+            <a:r>
+              <a:t>TRANSITION: "What we didn't solve."</a:t>
+            </a:r>
+          </a:p>
+          <a:p>
+            <a:r>
+              <a:t>[~40s]</a:t>
             </a:r>
           </a:p>
         </p:txBody>
@@ -2018,38 +2011,22 @@
           <a:lstStyle/>
           <a:p>
             <a:r>
-              <a:t>[~40s] Honest limits:</a:t>
-            </a:r>
-          </a:p>
-          <a:p>
-            <a:r>
-              <a:t>• No legal force</a:t>
-            </a:r>
-          </a:p>
-          <a:p>
-            <a:r>
-              <a:t>• One-dimensional (what, not who decides) — top priority extension</a:t>
-            </a:r>
-          </a:p>
-          <a:p>
-            <a:r>
-              <a:t>• Coverage gaps: artificial nutrition, antibiotics, comfort care</a:t>
-            </a:r>
-          </a:p>
-          <a:p>
-            <a:r>
-              <a:t>• Temporal: numeric hour bounds, not full temporal logic</a:t>
-            </a:r>
-          </a:p>
-          <a:p>
-            <a:r>
-              <a:t>• Gold standards team-authored; real EHR validation (MIMIC-IV) future</a:t>
-            </a:r>
-          </a:p>
-          <a:p/>
-          <a:p>
-            <a:r>
-              <a:t>Principle: surface uncertainty; don’t replace clinicians/surrogates.</a:t>
+              <a:t>NARRATIVE: Act IV — limits without retreating.</a:t>
+            </a:r>
+          </a:p>
+          <a:p>
+            <a:r>
+              <a:t>SAY: No legal force; one-dimensional (who-decides next); coverage gaps; team gold; EHR validation future.</a:t>
+            </a:r>
+          </a:p>
+          <a:p>
+            <a:r>
+              <a:t>TRANSITION: "Four takeaways."</a:t>
+            </a:r>
+          </a:p>
+          <a:p>
+            <a:r>
+              <a:t>[~35s]</a:t>
             </a:r>
           </a:p>
         </p:txBody>
@@ -2196,24 +2173,22 @@
           <a:lstStyle/>
           <a:p>
             <a:r>
-              <a:t>[~30s] Four takeaways on slide—read them, don’t rush.</a:t>
-            </a:r>
-          </a:p>
-          <a:p/>
-          <a:p>
-            <a:r>
-              <a:t>Close: Questions welcome.</a:t>
-            </a:r>
-          </a:p>
-          <a:p>
-            <a:r>
-              <a:t>Repo: https://github.com/patrickwalsh26/bmds210-AD_Ontology</a:t>
-            </a:r>
-          </a:p>
-          <a:p/>
-          <a:p>
-            <a:r>
-              <a:t>Q&amp;A prep: legal AD? No. Why not LLM only? Over-confident, not auditable. Weakest point? Team gold + P5 principled divergence.</a:t>
+              <a:t>NARRATIVE: Close.</a:t>
+            </a:r>
+          </a:p>
+          <a:p>
+            <a:r>
+              <a:t>SAY: Read four bullets. Repo URL. Questions welcome.</a:t>
+            </a:r>
+          </a:p>
+          <a:p>
+            <a:r>
+              <a:t>OFFER: "Happy to run demo scenario 1 live."</a:t>
+            </a:r>
+          </a:p>
+          <a:p>
+            <a:r>
+              <a:t>[~25s]</a:t>
             </a:r>
           </a:p>
         </p:txBody>
@@ -2360,31 +2335,27 @@
           <a:lstStyle/>
           <a:p>
             <a:r>
-              <a:t>[~45s] Three instruments, three jobs: advance directive (values/wishes), POLST (portable orders), code status (what we act on at 2 a.m.).</a:t>
-            </a:r>
-          </a:p>
-          <a:p/>
-          <a:p>
-            <a:r>
-              <a:t>The loss is in the middle—conditional wishes become coarse checkboxes or bedside orders.</a:t>
-            </a:r>
-          </a:p>
-          <a:p/>
-          <a:p>
-            <a:r>
-              <a:t>Important reframe (Magnus): the problem is NOT mainly “unreadable free text.” CA and UC forms are mostly checkboxes. They are low-resolution and disease-blind.</a:t>
-            </a:r>
-          </a:p>
-          <a:p/>
-          <a:p>
-            <a:r>
-              <a:t>Point to the ventilator example: temporary-if-reversible vs never-indefinitely cannot fit a yes/no box.</a:t>
-            </a:r>
-          </a:p>
-          <a:p/>
-          <a:p>
-            <a:r>
-              <a:t>Transition → why we scoped to advanced HF.</a:t>
+              <a:t>NARRATIVE: Act I — three instruments, translation loss.</a:t>
+            </a:r>
+          </a:p>
+          <a:p>
+            <a:r>
+              <a:t>SAY: AD → POLST → code status. Loss = conditional wishes → coarse boxes. "Free text" cliché is half wrong—CA/UC forms are checkboxes. Real problem: low resolution + disease blindness.</a:t>
+            </a:r>
+          </a:p>
+          <a:p>
+            <a:r>
+              <a:t>POINT AT: ventilator example on slide.</a:t>
+            </a:r>
+          </a:p>
+          <a:p>
+            <a:r>
+              <a:t>TRANSITION: "HF is where that blindness hurts most."</a:t>
+            </a:r>
+          </a:p>
+          <a:p>
+            <a:r>
+              <a:t>[~45s]</a:t>
             </a:r>
           </a:p>
         </p:txBody>
@@ -2531,25 +2502,22 @@
           <a:lstStyle/>
           <a:p>
             <a:r>
-              <a:t>[~40s] HF is unpredictable, device-dependent, and patients revisit the ED/ICU—preference interpretation is time-pressured and repeated.</a:t>
-            </a:r>
-          </a:p>
-          <a:p/>
-          <a:p>
-            <a:r>
-              <a:t>Five decision points on slide: CPR, ventilation, devices, vasopressors/inotropes, dialysis.</a:t>
-            </a:r>
-          </a:p>
-          <a:p/>
-          <a:p>
-            <a:r>
-              <a:t>~200K HF patients have ICDs; generic ADs rarely mention ICD/LVAD/inotropes—that gap motivates our scope.</a:t>
-            </a:r>
-          </a:p>
-          <a:p/>
-          <a:p>
-            <a:r>
-              <a:t>Transition → how we represent a preference computationally.</a:t>
+              <a:t>NARRATIVE: Act I — why HF scope.</a:t>
+            </a:r>
+          </a:p>
+          <a:p>
+            <a:r>
+              <a:t>SAY: Unpredictable, device-heavy, repeated ED/ICU visits. Five decision points. ICD/LVAD/inotropes missing from generic templates.</a:t>
+            </a:r>
+          </a:p>
+          <a:p>
+            <a:r>
+              <a:t>TRANSITION: "What's the smallest object that preserves patient logic?"</a:t>
+            </a:r>
+          </a:p>
+          <a:p>
+            <a:r>
+              <a:t>[~35s]</a:t>
             </a:r>
           </a:p>
         </p:txBody>
@@ -2696,25 +2664,22 @@
           <a:lstStyle/>
           <a:p>
             <a:r>
-              <a:t>[~45s] Core unit: PreferenceStatement = intervention + activation conditions + strength + negation + verbatim originalText.</a:t>
-            </a:r>
-          </a:p>
-          <a:p/>
-          <a:p>
-            <a:r>
-              <a:t>Walk the vasopressor example: 72h “no improvement” becomes a structured activation condition the reasoner can test.</a:t>
-            </a:r>
-          </a:p>
-          <a:p/>
-          <a:p>
-            <a:r>
-              <a:t>Why verbatim text? Auditable—clinicians see patient language behind the inference.</a:t>
-            </a:r>
-          </a:p>
-          <a:p/>
-          <a:p>
-            <a:r>
-              <a:t>Transition → ontology size and granularity.</a:t>
+              <a:t>NARRATIVE: Act II begins — PreferenceStatement.</a:t>
+            </a:r>
+          </a:p>
+          <a:p>
+            <a:r>
+              <a:t>SAY: Intervention + activation conditions + strength + negation + verbatim text. Reasoner asks: does this apply in THIS scenario? Walk 72h vasopressor example.</a:t>
+            </a:r>
+          </a:p>
+          <a:p>
+            <a:r>
+              <a:t>TRANSITION: "How much structure we built around that."</a:t>
+            </a:r>
+          </a:p>
+          <a:p>
+            <a:r>
+              <a:t>[~45s]</a:t>
             </a:r>
           </a:p>
         </p:txBody>
@@ -2861,19 +2826,22 @@
           <a:lstStyle/>
           <a:p>
             <a:r>
-              <a:t>[~40s] 67 classes, 22 properties, 21 intervention subclasses—finer than any single template in our 50-form inventory (e.g., six ventilation types vs one checkbox).</a:t>
-            </a:r>
-          </a:p>
-          <a:p/>
-          <a:p>
-            <a:r>
-              <a:t>SNOMED CT grounding where possible for interoperability.</a:t>
-            </a:r>
-          </a:p>
-          <a:p/>
-          <a:p>
-            <a:r>
-              <a:t>Transition → we don’t force binary answers.</a:t>
+              <a:t>NARRATIVE: Act II — ontology credibility.</a:t>
+            </a:r>
+          </a:p>
+          <a:p>
+            <a:r>
+              <a:t>SAY: 67 classes, 22 properties, 21 interventions—finer than our 50-form inventory. SNOMED where possible.</a:t>
+            </a:r>
+          </a:p>
+          <a:p>
+            <a:r>
+              <a:t>TRANSITION: "Granularity only helps if we know when NOT to answer."</a:t>
+            </a:r>
+          </a:p>
+          <a:p>
+            <a:r>
+              <a:t>[~35s]</a:t>
             </a:r>
           </a:p>
         </p:txBody>
@@ -3020,39 +2988,22 @@
           <a:lstStyle/>
           <a:p>
             <a:r>
-              <a:t>[~45s] Four honest outputs:</a:t>
-            </a:r>
-          </a:p>
-          <a:p>
-            <a:r>
-              <a:t>• Clear — conditions met, unambiguous</a:t>
-            </a:r>
-          </a:p>
-          <a:p>
-            <a:r>
-              <a:t>• Partial — some conditions unmet → defer to surrogate</a:t>
-            </a:r>
-          </a:p>
-          <a:p>
-            <a:r>
-              <a:t>• No coverage — directive silent; do NOT presume</a:t>
-            </a:r>
-          </a:p>
-          <a:p>
-            <a:r>
-              <a:t>• Vague — surface imprecise language (“no heroic measures”)</a:t>
-            </a:r>
-          </a:p>
-          <a:p/>
-          <a:p>
-            <a:r>
-              <a:t>Safety feature: uncertainty is visible. A checkbox or overconfident LLM cannot say “I don’t know.”</a:t>
-            </a:r>
-          </a:p>
-          <a:p/>
-          <a:p>
-            <a:r>
-              <a:t>Transition → end-to-end pipeline.</a:t>
+              <a:t>NARRATIVE: Act II — safety thesis (four honest outputs).</a:t>
+            </a:r>
+          </a:p>
+          <a:p>
+            <a:r>
+              <a:t>SAY: Clear / Partial / No coverage / Vague. Punchline: checkbox or LLM can't say "I don't know." ADO can.</a:t>
+            </a:r>
+          </a:p>
+          <a:p>
+            <a:r>
+              <a:t>TRANSITION: "How we wired that into a pipeline."</a:t>
+            </a:r>
+          </a:p>
+          <a:p>
+            <a:r>
+              <a:t>[~40s]</a:t>
             </a:r>
           </a:p>
         </p:txBody>
@@ -3199,25 +3150,27 @@
           <a:lstStyle/>
           <a:p>
             <a:r>
-              <a:t>[~45s] LLMs ONLY at the boundary. Closed-world extraction → validated JSON → OWL individuals → deterministic scenario reasoner → four-category output + code status/POLST.</a:t>
-            </a:r>
-          </a:p>
-          <a:p/>
-          <a:p>
-            <a:r>
-              <a:t>Closed-world rule: extract only what the patient stated; out-of-scope text (nutrition, antibiotics) must NOT map to nearest class—that enables trustworthy “no coverage.”</a:t>
-            </a:r>
-          </a:p>
-          <a:p/>
-          <a:p>
-            <a:r>
-              <a:t>Tagline: ontology WITH LLMs, not versus LLMs.</a:t>
-            </a:r>
-          </a:p>
-          <a:p/>
-          <a:p>
-            <a:r>
-              <a:t>Transition → how we evaluated.</a:t>
+              <a:t>NARRATIVE: Act II — architecture.</a:t>
+            </a:r>
+          </a:p>
+          <a:p>
+            <a:r>
+              <a:t>SAY: LLMs extract ONLY. Ontology = auditable truth. Reasoner decides. Closed-world: out-of-scope → extract nothing. Tagline: WITH LLMs, not vs.</a:t>
+            </a:r>
+          </a:p>
+          <a:p>
+            <a:r>
+              <a:t>OPTIONAL: "We can demo scenario 1 live after results."</a:t>
+            </a:r>
+          </a:p>
+          <a:p>
+            <a:r>
+              <a:t>TRANSITION: "We tested that three ways."</a:t>
+            </a:r>
+          </a:p>
+          <a:p>
+            <a:r>
+              <a:t>[~45s]</a:t>
             </a:r>
           </a:p>
         </p:txBody>
@@ -3364,38 +3317,27 @@
           <a:lstStyle/>
           <a:p>
             <a:r>
-              <a:t>[~50s] Five evaluation strands:</a:t>
-            </a:r>
-          </a:p>
-          <a:p>
-            <a:r>
-              <a:t>1) Pipeline: example patient populates end-to-end (9 prefs, 50 individuals).</a:t>
-            </a:r>
-          </a:p>
-          <a:p>
-            <a:r>
-              <a:t>2) 16 vignettes, all decision points &amp; output types; gold = team-adjudicated expected answers.</a:t>
-            </a:r>
-          </a:p>
-          <a:p>
-            <a:r>
-              <a:t>3) Ablation (post-hoc sensitivity): re-score vignettes ignoring activation conditions → 12/16 (75%) vs 16/16 (100%). All four errors are conditional/partial cases—shows condition modeling matters. (Document as sensitivity analysis, not a separate SWRL experiment.)</a:t>
-            </a:r>
-          </a:p>
-          <a:p>
-            <a:r>
-              <a:t>4) LLM extraction: 12 real-template statements + 2 out-of-scope tests.</a:t>
-            </a:r>
-          </a:p>
-          <a:p>
-            <a:r>
-              <a:t>5) Track 3: 12 profiles → code status/POLST vs POLST semantics gold + Magnus expert review.</a:t>
-            </a:r>
-          </a:p>
-          <a:p/>
-          <a:p>
-            <a:r>
-              <a:t>Caveat if asked: gold is team-authored but grounded in real templates and independent POLST definitions; blind rater sheets in repo.</a:t>
+              <a:t>NARRATIVE: Act III — earn trust before numbers.</a:t>
+            </a:r>
+          </a:p>
+          <a:p>
+            <a:r>
+              <a:t>SAY: 5 evaluation strands on slide. Caveat: team gold, grounded in real templates + POLST semantics. Ablation = same 16 vignettes without conditions → 75%.</a:t>
+            </a:r>
+          </a:p>
+          <a:p>
+            <a:r>
+              <a:t>POINT AT: vignette pie chart (if visible).</a:t>
+            </a:r>
+          </a:p>
+          <a:p>
+            <a:r>
+              <a:t>TRANSITION: "Here's what we found."</a:t>
+            </a:r>
+          </a:p>
+          <a:p>
+            <a:r>
+              <a:t>[~45s]</a:t>
             </a:r>
           </a:p>
         </p:txBody>
@@ -3542,37 +3484,27 @@
           <a:lstStyle/>
           <a:p>
             <a:r>
-              <a:t>[~60s — FLAGSHIP] Track 1: 16/16 decision AND match-type accuracy on vignettes.</a:t>
-            </a:r>
-          </a:p>
-          <a:p/>
-          <a:p>
-            <a:r>
-              <a:t>Track 2: Precision 0.94, recall 1.00, F1 0.97; negation/type/conditionality 15/15; ZERO hallucinations on out-of-scope nutrition &amp; antibiotics.</a:t>
-            </a:r>
-          </a:p>
-          <a:p/>
-          <a:p>
-            <a:r>
-              <a:t>Track 3: 12 real template profiles → 35/36 field agreement (97%): code status 12/12, POLST A 12/12, POLST B 11/12, exact profile 11/12; κ = 1.00 / 1.00 / 0.88.</a:t>
-            </a:r>
-          </a:p>
-          <a:p/>
-          <a:p>
-            <a:r>
-              <a:t>Ablation: ignoring conditions → 75% (4 false-confident errors on conditional vignettes).</a:t>
-            </a:r>
-          </a:p>
-          <a:p/>
-          <a:p>
-            <a:r>
-              <a:t>If time: P9 vs P10 same directive flips DNR↔Full code; P5 “miss” is principled (Not specified vs presuming Full Treatment).</a:t>
-            </a:r>
-          </a:p>
-          <a:p/>
-          <a:p>
-            <a:r>
-              <a:t>Transition → concrete if/then example.</a:t>
+              <a:t>NARRATIVE: Act III — flagship results.</a:t>
+            </a:r>
+          </a:p>
+          <a:p>
+            <a:r>
+              <a:t>SAY: Track 1: 16/16. Track 2: F1 0.97, 0 hallucinations on nutrition/antibiotics. Track 3: 35/36 (97%), κ 1.00/1.00/0.88. Ablation: 75% without conditions = 4 false-confident conditional errors.</a:t>
+            </a:r>
+          </a:p>
+          <a:p>
+            <a:r>
+              <a:t>POINT AT: bar charts on right of slide.</a:t>
+            </a:r>
+          </a:p>
+          <a:p>
+            <a:r>
+              <a:t>TRANSITION: "One profile pair shows the clinical payoff."</a:t>
+            </a:r>
+          </a:p>
+          <a:p>
+            <a:r>
+              <a:t>[~55s]</a:t>
             </a:r>
           </a:p>
         </p:txBody>
@@ -6035,6 +5967,30 @@
           </a:p>
         </p:txBody>
       </p:sp>
+      <p:pic>
+        <p:nvPicPr>
+          <p:cNvPr id="239" name="Picture 238" descr="conditional_p9_p10.png"/>
+          <p:cNvPicPr>
+            <a:picLocks noChangeAspect="1"/>
+          </p:cNvPicPr>
+          <p:nvPr/>
+        </p:nvPicPr>
+        <p:blipFill>
+          <a:blip r:embed="rId3"/>
+          <a:stretch>
+            <a:fillRect/>
+          </a:stretch>
+        </p:blipFill>
+        <p:spPr>
+          <a:xfrm>
+            <a:off x="6583680" y="1371600"/>
+            <a:ext cx="5303520" cy="2426717"/>
+          </a:xfrm>
+          <a:prstGeom prst="rect">
+            <a:avLst/>
+          </a:prstGeom>
+        </p:spPr>
+      </p:pic>
     </p:spTree>
   </p:cSld>
   <p:clrMapOvr>
@@ -9040,6 +8996,128 @@
 </p:sld>
 </file>
 
+<file path=ppt/slides/slide14.xml><?xml version="1.0" encoding="utf-8"?>
+<p:sld xmlns:a="http://schemas.openxmlformats.org/drawingml/2006/main" xmlns:p="http://schemas.openxmlformats.org/presentationml/2006/main" xmlns:r="http://schemas.openxmlformats.org/officeDocument/2006/relationships">
+  <p:cSld>
+    <p:spTree>
+      <p:nvGrpSpPr>
+        <p:cNvPr id="1" name=""/>
+        <p:cNvGrpSpPr/>
+        <p:nvPr/>
+      </p:nvGrpSpPr>
+      <p:grpSpPr/>
+      <p:sp>
+        <p:nvSpPr>
+          <p:cNvPr id="2" name="TextBox 1"/>
+          <p:cNvSpPr txBox="1"/>
+          <p:nvPr/>
+        </p:nvSpPr>
+        <p:spPr>
+          <a:xfrm>
+            <a:off x="457200" y="320040"/>
+            <a:ext cx="10972800" cy="548640"/>
+          </a:xfrm>
+          <a:prstGeom prst="rect">
+            <a:avLst/>
+          </a:prstGeom>
+          <a:noFill/>
+        </p:spPr>
+        <p:txBody>
+          <a:bodyPr wrap="none">
+            <a:spAutoFit/>
+          </a:bodyPr>
+          <a:lstStyle/>
+          <a:p>
+            <a:r>
+              <a:t>EVALUATION FIGURES — Track 3 &amp; code-status fidelity</a:t>
+            </a:r>
+          </a:p>
+        </p:txBody>
+      </p:sp>
+      <p:pic>
+        <p:nvPicPr>
+          <p:cNvPr id="3" name="Picture 2" descr="track3_field_agreement.png"/>
+          <p:cNvPicPr>
+            <a:picLocks noChangeAspect="1"/>
+          </p:cNvPicPr>
+          <p:nvPr/>
+        </p:nvPicPr>
+        <p:blipFill>
+          <a:blip r:embed="rId2"/>
+          <a:stretch>
+            <a:fillRect/>
+          </a:stretch>
+        </p:blipFill>
+        <p:spPr>
+          <a:xfrm>
+            <a:off x="365760" y="914400"/>
+            <a:ext cx="5669280" cy="3137742"/>
+          </a:xfrm>
+          <a:prstGeom prst="rect">
+            <a:avLst/>
+          </a:prstGeom>
+        </p:spPr>
+      </p:pic>
+      <p:pic>
+        <p:nvPicPr>
+          <p:cNvPr id="4" name="Picture 3" descr="code_status_confusion.png"/>
+          <p:cNvPicPr>
+            <a:picLocks noChangeAspect="1"/>
+          </p:cNvPicPr>
+          <p:nvPr/>
+        </p:nvPicPr>
+        <p:blipFill>
+          <a:blip r:embed="rId3"/>
+          <a:stretch>
+            <a:fillRect/>
+          </a:stretch>
+        </p:blipFill>
+        <p:spPr>
+          <a:xfrm>
+            <a:off x="6217920" y="914400"/>
+            <a:ext cx="5669280" cy="4842927"/>
+          </a:xfrm>
+          <a:prstGeom prst="rect">
+            <a:avLst/>
+          </a:prstGeom>
+        </p:spPr>
+      </p:pic>
+      <p:sp>
+        <p:nvSpPr>
+          <p:cNvPr id="5" name="TextBox 4"/>
+          <p:cNvSpPr txBox="1"/>
+          <p:nvPr/>
+        </p:nvSpPr>
+        <p:spPr>
+          <a:xfrm>
+            <a:off x="457200" y="6035040"/>
+            <a:ext cx="11247120" cy="457200"/>
+          </a:xfrm>
+          <a:prstGeom prst="rect">
+            <a:avLst/>
+          </a:prstGeom>
+          <a:noFill/>
+        </p:spPr>
+        <p:txBody>
+          <a:bodyPr wrap="none">
+            <a:spAutoFit/>
+          </a:bodyPr>
+          <a:lstStyle/>
+          <a:p>
+            <a:r>
+              <a:t>12 real-world template profiles • Gold = POLST semantics • Diagonal confusion matrix = agreement across all observed code-status categories</a:t>
+            </a:r>
+          </a:p>
+        </p:txBody>
+      </p:sp>
+    </p:spTree>
+  </p:cSld>
+  <p:clrMapOvr>
+    <a:masterClrMapping/>
+  </p:clrMapOvr>
+</p:sld>
+</file>
+
 <file path=ppt/slides/slide2.xml><?xml version="1.0" encoding="utf-8"?>
 <p:sld xmlns:a="http://schemas.openxmlformats.org/drawingml/2006/main" xmlns:r="http://schemas.openxmlformats.org/officeDocument/2006/relationships" xmlns:mc="http://schemas.openxmlformats.org/markup-compatibility/2006" xmlns:mv="urn:schemas-microsoft-com:mac:vml" xmlns:p="http://schemas.openxmlformats.org/presentationml/2006/main" xmlns:c="http://schemas.openxmlformats.org/drawingml/2006/chart" xmlns:dgm="http://schemas.openxmlformats.org/drawingml/2006/diagram" xmlns:o="urn:schemas-microsoft-com:office:office" xmlns:v="urn:schemas-microsoft-com:vml" xmlns:pvml="urn:schemas-microsoft-com:office:powerpoint" xmlns:com="http://schemas.openxmlformats.org/drawingml/2006/compatibility" xmlns:p14="http://schemas.microsoft.com/office/powerpoint/2010/main" xmlns:p15="http://schemas.microsoft.com/office/powerpoint/2012/main" xmlns:ahyp="http://schemas.microsoft.com/office/drawing/2018/hyperlinkcolor">
   <p:cSld>
@@ -18502,6 +18580,30 @@
           </a:p>
         </p:txBody>
       </p:sp>
+      <p:pic>
+        <p:nvPicPr>
+          <p:cNvPr id="191" name="Picture 190" descr="vignette_match_types.png"/>
+          <p:cNvPicPr>
+            <a:picLocks noChangeAspect="1"/>
+          </p:cNvPicPr>
+          <p:nvPr/>
+        </p:nvPicPr>
+        <p:blipFill>
+          <a:blip r:embed="rId3"/>
+          <a:stretch>
+            <a:fillRect/>
+          </a:stretch>
+        </p:blipFill>
+        <p:spPr>
+          <a:xfrm>
+            <a:off x="7772400" y="1097280"/>
+            <a:ext cx="4114800" cy="3788660"/>
+          </a:xfrm>
+          <a:prstGeom prst="rect">
+            <a:avLst/>
+          </a:prstGeom>
+        </p:spPr>
+      </p:pic>
     </p:spTree>
   </p:cSld>
   <p:clrMapOvr>
@@ -19368,7 +19470,6 @@
           <a:lstStyle/>
           <a:p>
             <a:r>
-              <a:rPr sz="1400"/>
               <a:t>κ=1.00 / 1.00 / 0.88</a:t>
             </a:r>
           </a:p>
@@ -19953,6 +20054,54 @@
           </a:p>
         </p:txBody>
       </p:sp>
+      <p:pic>
+        <p:nvPicPr>
+          <p:cNvPr id="222" name="Picture 221" descr="eval_overview.png"/>
+          <p:cNvPicPr>
+            <a:picLocks noChangeAspect="1"/>
+          </p:cNvPicPr>
+          <p:nvPr/>
+        </p:nvPicPr>
+        <p:blipFill>
+          <a:blip r:embed="rId3"/>
+          <a:stretch>
+            <a:fillRect/>
+          </a:stretch>
+        </p:blipFill>
+        <p:spPr>
+          <a:xfrm>
+            <a:off x="6217920" y="1234440"/>
+            <a:ext cx="5486400" cy="2843797"/>
+          </a:xfrm>
+          <a:prstGeom prst="rect">
+            <a:avLst/>
+          </a:prstGeom>
+        </p:spPr>
+      </p:pic>
+      <p:pic>
+        <p:nvPicPr>
+          <p:cNvPr id="223" name="Picture 222" descr="ablation_conditions.png"/>
+          <p:cNvPicPr>
+            <a:picLocks noChangeAspect="1"/>
+          </p:cNvPicPr>
+          <p:nvPr/>
+        </p:nvPicPr>
+        <p:blipFill>
+          <a:blip r:embed="rId4"/>
+          <a:stretch>
+            <a:fillRect/>
+          </a:stretch>
+        </p:blipFill>
+        <p:spPr>
+          <a:xfrm>
+            <a:off x="6217920" y="3703320"/>
+            <a:ext cx="5486400" cy="3624758"/>
+          </a:xfrm>
+          <a:prstGeom prst="rect">
+            <a:avLst/>
+          </a:prstGeom>
+        </p:spPr>
+      </p:pic>
     </p:spTree>
   </p:cSld>
   <p:clrMapOvr>

</xml_diff>

<commit_message>
Add Protégé showcase guide and ontology figure for class presentation
- Protege_Showcase_Guide.md: live walkthrough script (classes, Jane Doe, HermiT)
- ontology_class_hierarchy.png on slide 5; integrate with Live_Demo_Guide
- Combined Protégé + terminal demo path; update speaker notes and README

Co-authored-by: patrickwalsh26 <patrickwalsh26@users.noreply.github.com>
</commit_message>
<xml_diff>
--- a/ADO_powerpoint_presentation.pptx
+++ b/ADO_powerpoint_presentation.pptx
@@ -2836,12 +2836,17 @@
           </a:p>
           <a:p>
             <a:r>
+              <a:t>OPTIONAL LIVE: Open Protégé → ado_jane_doe_001.owl → expand Intervention tree (see Protege_Showcase_Guide.md). POINT AT hierarchy figure on slide.</a:t>
+            </a:r>
+          </a:p>
+          <a:p>
+            <a:r>
               <a:t>TRANSITION: "Granularity only helps if we know when NOT to answer."</a:t>
             </a:r>
           </a:p>
           <a:p>
             <a:r>
-              <a:t>[~35s]</a:t>
+              <a:t>[~35s, +2 min if Protégé live]</a:t>
             </a:r>
           </a:p>
         </p:txBody>
@@ -14481,6 +14486,30 @@
           </a:p>
         </p:txBody>
       </p:sp>
+      <p:pic>
+        <p:nvPicPr>
+          <p:cNvPr id="119" name="Picture 118" descr="ontology_class_hierarchy.png"/>
+          <p:cNvPicPr>
+            <a:picLocks noChangeAspect="1"/>
+          </p:cNvPicPr>
+          <p:nvPr/>
+        </p:nvPicPr>
+        <p:blipFill>
+          <a:blip r:embed="rId3"/>
+          <a:stretch>
+            <a:fillRect/>
+          </a:stretch>
+        </p:blipFill>
+        <p:spPr>
+          <a:xfrm>
+            <a:off x="6309360" y="1051560"/>
+            <a:ext cx="5394960" cy="3329063"/>
+          </a:xfrm>
+          <a:prstGeom prst="rect">
+            <a:avLst/>
+          </a:prstGeom>
+        </p:spPr>
+      </p:pic>
     </p:spTree>
   </p:cSld>
   <p:clrMapOvr>

</xml_diff>

<commit_message>
Add evaluation figures to PowerPoint and PPT placement guide
- Regenerate figures: 69% ablation, coverage inventory, vignette splits, extraction F1
- New STRENGTHENED EVALUATION slide with six-panel layout
- docs/PPT_Figures_Guide.md with exact numbers per slide

Co-authored-by: patrickwalsh26 <patrickwalsh26@users.noreply.github.com>
</commit_message>
<xml_diff>
--- a/ADO_powerpoint_presentation.pptx
+++ b/ADO_powerpoint_presentation.pptx
@@ -22,6 +22,7 @@
     <p:sldId id="267" r:id="rId16"/>
     <p:sldId id="268" r:id="rId17"/>
     <p:sldId id="269" r:id="rId19"/>
+    <p:sldId id="270" r:id="rId20"/>
   </p:sldIdLst>
   <p:sldSz cy="6858000" cx="12191675"/>
   <p:notesSz cx="6858000" cy="12191675"/>
@@ -5996,6 +5997,30 @@
           </a:prstGeom>
         </p:spPr>
       </p:pic>
+      <p:pic>
+        <p:nvPicPr>
+          <p:cNvPr id="240" name="Picture 239" descr="image.png"/>
+          <p:cNvPicPr>
+            <a:picLocks noChangeAspect="1"/>
+          </p:cNvPicPr>
+          <p:nvPr/>
+        </p:nvPicPr>
+        <p:blipFill>
+          <a:blip r:embed="rId3"/>
+          <a:stretch>
+            <a:fillRect/>
+          </a:stretch>
+        </p:blipFill>
+        <p:spPr>
+          <a:xfrm>
+            <a:off x="6400800" y="1325880"/>
+            <a:ext cx="5394960" cy="2468557"/>
+          </a:xfrm>
+          <a:prstGeom prst="rect">
+            <a:avLst/>
+          </a:prstGeom>
+        </p:spPr>
+      </p:pic>
     </p:spTree>
   </p:cSld>
   <p:clrMapOvr>
@@ -9123,6 +9148,227 @@
 </p:sld>
 </file>
 
+<file path=ppt/slides/slide15.xml><?xml version="1.0" encoding="utf-8"?>
+<p:sld xmlns:a="http://schemas.openxmlformats.org/drawingml/2006/main" xmlns:p="http://schemas.openxmlformats.org/presentationml/2006/main" xmlns:r="http://schemas.openxmlformats.org/officeDocument/2006/relationships">
+  <p:cSld>
+    <p:spTree>
+      <p:nvGrpSpPr>
+        <p:cNvPr id="1" name=""/>
+        <p:cNvGrpSpPr/>
+        <p:nvPr/>
+      </p:nvGrpSpPr>
+      <p:grpSpPr/>
+      <p:sp>
+        <p:nvSpPr>
+          <p:cNvPr id="2" name="TextBox 1"/>
+          <p:cNvSpPr txBox="1"/>
+          <p:nvPr/>
+        </p:nvSpPr>
+        <p:spPr>
+          <a:xfrm>
+            <a:off x="365760" y="228600"/>
+            <a:ext cx="11430000" cy="502920"/>
+          </a:xfrm>
+          <a:prstGeom prst="rect">
+            <a:avLst/>
+          </a:prstGeom>
+          <a:noFill/>
+        </p:spPr>
+        <p:txBody>
+          <a:bodyPr wrap="none">
+            <a:spAutoFit/>
+          </a:bodyPr>
+          <a:lstStyle/>
+          <a:p>
+            <a:pPr>
+              <a:defRPr sz="1800" b="1"/>
+            </a:pPr>
+            <a:r>
+              <a:t>STRENGTHENED EVALUATION — developmental validation (report / June 2026)</a:t>
+            </a:r>
+          </a:p>
+        </p:txBody>
+      </p:sp>
+      <p:pic>
+        <p:nvPicPr>
+          <p:cNvPr id="3" name="Picture 2" descr="vignette_splits.png"/>
+          <p:cNvPicPr>
+            <a:picLocks noChangeAspect="1"/>
+          </p:cNvPicPr>
+          <p:nvPr/>
+        </p:nvPicPr>
+        <p:blipFill>
+          <a:blip r:embed="rId2"/>
+          <a:stretch>
+            <a:fillRect/>
+          </a:stretch>
+        </p:blipFill>
+        <p:spPr>
+          <a:xfrm>
+            <a:off x="320040" y="868680"/>
+            <a:ext cx="2788920" cy="1963197"/>
+          </a:xfrm>
+          <a:prstGeom prst="rect">
+            <a:avLst/>
+          </a:prstGeom>
+        </p:spPr>
+      </p:pic>
+      <p:pic>
+        <p:nvPicPr>
+          <p:cNvPr id="4" name="Picture 3" descr="ablation_conditions.png"/>
+          <p:cNvPicPr>
+            <a:picLocks noChangeAspect="1"/>
+          </p:cNvPicPr>
+          <p:nvPr/>
+        </p:nvPicPr>
+        <p:blipFill>
+          <a:blip r:embed="rId3"/>
+          <a:stretch>
+            <a:fillRect/>
+          </a:stretch>
+        </p:blipFill>
+        <p:spPr>
+          <a:xfrm>
+            <a:off x="3154680" y="868680"/>
+            <a:ext cx="2788920" cy="1625901"/>
+          </a:xfrm>
+          <a:prstGeom prst="rect">
+            <a:avLst/>
+          </a:prstGeom>
+        </p:spPr>
+      </p:pic>
+      <p:pic>
+        <p:nvPicPr>
+          <p:cNvPr id="5" name="Picture 4" descr="coverage_inventory.png"/>
+          <p:cNvPicPr>
+            <a:picLocks noChangeAspect="1"/>
+          </p:cNvPicPr>
+          <p:nvPr/>
+        </p:nvPicPr>
+        <p:blipFill>
+          <a:blip r:embed="rId4"/>
+          <a:stretch>
+            <a:fillRect/>
+          </a:stretch>
+        </p:blipFill>
+        <p:spPr>
+          <a:xfrm>
+            <a:off x="5989320" y="868680"/>
+            <a:ext cx="5486400" cy="2834188"/>
+          </a:xfrm>
+          <a:prstGeom prst="rect">
+            <a:avLst/>
+          </a:prstGeom>
+        </p:spPr>
+      </p:pic>
+      <p:pic>
+        <p:nvPicPr>
+          <p:cNvPr id="6" name="Picture 5" descr="extraction_f1.png"/>
+          <p:cNvPicPr>
+            <a:picLocks noChangeAspect="1"/>
+          </p:cNvPicPr>
+          <p:nvPr/>
+        </p:nvPicPr>
+        <p:blipFill>
+          <a:blip r:embed="rId5"/>
+          <a:stretch>
+            <a:fillRect/>
+          </a:stretch>
+        </p:blipFill>
+        <p:spPr>
+          <a:xfrm>
+            <a:off x="320040" y="3703320"/>
+            <a:ext cx="2788920" cy="1746703"/>
+          </a:xfrm>
+          <a:prstGeom prst="rect">
+            <a:avLst/>
+          </a:prstGeom>
+        </p:spPr>
+      </p:pic>
+      <p:pic>
+        <p:nvPicPr>
+          <p:cNvPr id="7" name="Picture 6" descr="image.png"/>
+          <p:cNvPicPr>
+            <a:picLocks noChangeAspect="1"/>
+          </p:cNvPicPr>
+          <p:nvPr/>
+        </p:nvPicPr>
+        <p:blipFill>
+          <a:blip r:embed="rId6"/>
+          <a:stretch>
+            <a:fillRect/>
+          </a:stretch>
+        </p:blipFill>
+        <p:spPr>
+          <a:xfrm>
+            <a:off x="3154680" y="3703320"/>
+            <a:ext cx="2788920" cy="1543566"/>
+          </a:xfrm>
+          <a:prstGeom prst="rect">
+            <a:avLst/>
+          </a:prstGeom>
+        </p:spPr>
+      </p:pic>
+      <p:pic>
+        <p:nvPicPr>
+          <p:cNvPr id="8" name="Picture 7" descr="image.png"/>
+          <p:cNvPicPr>
+            <a:picLocks noChangeAspect="1"/>
+          </p:cNvPicPr>
+          <p:nvPr/>
+        </p:nvPicPr>
+        <p:blipFill>
+          <a:blip r:embed="rId7"/>
+          <a:stretch>
+            <a:fillRect/>
+          </a:stretch>
+        </p:blipFill>
+        <p:spPr>
+          <a:xfrm>
+            <a:off x="5989320" y="3703320"/>
+            <a:ext cx="5486400" cy="4686704"/>
+          </a:xfrm>
+          <a:prstGeom prst="rect">
+            <a:avLst/>
+          </a:prstGeom>
+        </p:spPr>
+      </p:pic>
+      <p:sp>
+        <p:nvSpPr>
+          <p:cNvPr id="9" name="TextBox 8"/>
+          <p:cNvSpPr txBox="1"/>
+          <p:nvPr/>
+        </p:nvSpPr>
+        <p:spPr>
+          <a:xfrm>
+            <a:off x="365760" y="6172200"/>
+            <a:ext cx="11247120" cy="411480"/>
+          </a:xfrm>
+          <a:prstGeom prst="rect">
+            <a:avLst/>
+          </a:prstGeom>
+          <a:noFill/>
+        </p:spPr>
+        <p:txBody>
+          <a:bodyPr wrap="none">
+            <a:spAutoFit/>
+          </a:bodyPr>
+          <a:lstStyle/>
+          <a:p>
+            <a:r>
+              <a:t>Developmental validation — not clinical trial. Team gold; single patient ontology. Lead with ablation (69%) + coverage (47% fully representable), not only 100% vignettes.</a:t>
+            </a:r>
+          </a:p>
+        </p:txBody>
+      </p:sp>
+    </p:spTree>
+  </p:cSld>
+  <p:clrMapOvr>
+    <a:masterClrMapping/>
+  </p:clrMapOvr>
+</p:sld>
+</file>
+
 <file path=ppt/slides/slide2.xml><?xml version="1.0" encoding="utf-8"?>
 <p:sld xmlns:a="http://schemas.openxmlformats.org/drawingml/2006/main" xmlns:r="http://schemas.openxmlformats.org/officeDocument/2006/relationships" xmlns:mc="http://schemas.openxmlformats.org/markup-compatibility/2006" xmlns:mv="urn:schemas-microsoft-com:mac:vml" xmlns:p="http://schemas.openxmlformats.org/presentationml/2006/main" xmlns:c="http://schemas.openxmlformats.org/drawingml/2006/chart" xmlns:dgm="http://schemas.openxmlformats.org/drawingml/2006/diagram" xmlns:o="urn:schemas-microsoft-com:office:office" xmlns:v="urn:schemas-microsoft-com:vml" xmlns:pvml="urn:schemas-microsoft-com:office:powerpoint" xmlns:com="http://schemas.openxmlformats.org/drawingml/2006/compatibility" xmlns:p14="http://schemas.microsoft.com/office/powerpoint/2010/main" xmlns:p15="http://schemas.microsoft.com/office/powerpoint/2012/main" xmlns:ahyp="http://schemas.microsoft.com/office/drawing/2018/hyperlinkcolor">
   <p:cSld>
@@ -14489,6 +14735,30 @@
       <p:pic>
         <p:nvPicPr>
           <p:cNvPr id="119" name="Picture 118" descr="ontology_class_hierarchy.png"/>
+          <p:cNvPicPr>
+            <a:picLocks noChangeAspect="1"/>
+          </p:cNvPicPr>
+          <p:nvPr/>
+        </p:nvPicPr>
+        <p:blipFill>
+          <a:blip r:embed="rId3"/>
+          <a:stretch>
+            <a:fillRect/>
+          </a:stretch>
+        </p:blipFill>
+        <p:spPr>
+          <a:xfrm>
+            <a:off x="6309360" y="1051560"/>
+            <a:ext cx="5394960" cy="3329063"/>
+          </a:xfrm>
+          <a:prstGeom prst="rect">
+            <a:avLst/>
+          </a:prstGeom>
+        </p:spPr>
+      </p:pic>
+      <p:pic>
+        <p:nvPicPr>
+          <p:cNvPr id="120" name="Picture 119" descr="image.png"/>
           <p:cNvPicPr>
             <a:picLocks noChangeAspect="1"/>
           </p:cNvPicPr>
@@ -18633,6 +18903,30 @@
           </a:prstGeom>
         </p:spPr>
       </p:pic>
+      <p:pic>
+        <p:nvPicPr>
+          <p:cNvPr id="192" name="Picture 191" descr="image.png"/>
+          <p:cNvPicPr>
+            <a:picLocks noChangeAspect="1"/>
+          </p:cNvPicPr>
+          <p:nvPr/>
+        </p:nvPicPr>
+        <p:blipFill>
+          <a:blip r:embed="rId3"/>
+          <a:stretch>
+            <a:fillRect/>
+          </a:stretch>
+        </p:blipFill>
+        <p:spPr>
+          <a:xfrm>
+            <a:off x="7498079" y="1051560"/>
+            <a:ext cx="3931920" cy="3620275"/>
+          </a:xfrm>
+          <a:prstGeom prst="rect">
+            <a:avLst/>
+          </a:prstGeom>
+        </p:spPr>
+      </p:pic>
     </p:spTree>
   </p:cSld>
   <p:clrMapOvr>
@@ -20125,6 +20419,54 @@
           <a:xfrm>
             <a:off x="6217920" y="3703320"/>
             <a:ext cx="5486400" cy="3624758"/>
+          </a:xfrm>
+          <a:prstGeom prst="rect">
+            <a:avLst/>
+          </a:prstGeom>
+        </p:spPr>
+      </p:pic>
+      <p:pic>
+        <p:nvPicPr>
+          <p:cNvPr id="224" name="Picture 223" descr="eval_overview.png"/>
+          <p:cNvPicPr>
+            <a:picLocks noChangeAspect="1"/>
+          </p:cNvPicPr>
+          <p:nvPr/>
+        </p:nvPicPr>
+        <p:blipFill>
+          <a:blip r:embed="rId5"/>
+          <a:stretch>
+            <a:fillRect/>
+          </a:stretch>
+        </p:blipFill>
+        <p:spPr>
+          <a:xfrm>
+            <a:off x="6126480" y="1097280"/>
+            <a:ext cx="5577840" cy="2854953"/>
+          </a:xfrm>
+          <a:prstGeom prst="rect">
+            <a:avLst/>
+          </a:prstGeom>
+        </p:spPr>
+      </p:pic>
+      <p:pic>
+        <p:nvPicPr>
+          <p:cNvPr id="225" name="Picture 224" descr="ablation_conditions.png"/>
+          <p:cNvPicPr>
+            <a:picLocks noChangeAspect="1"/>
+          </p:cNvPicPr>
+          <p:nvPr/>
+        </p:nvPicPr>
+        <p:blipFill>
+          <a:blip r:embed="rId6"/>
+          <a:stretch>
+            <a:fillRect/>
+          </a:stretch>
+        </p:blipFill>
+        <p:spPr>
+          <a:xfrm>
+            <a:off x="6126480" y="3611880"/>
+            <a:ext cx="5577840" cy="3251802"/>
           </a:xfrm>
           <a:prstGeom prst="rect">
             <a:avLst/>

</xml_diff>

<commit_message>
Add high-DPI presentation figures and revised slide breakdown
- Regenerate all evaluation figures at 300 DPI
- New figures: eval_two_layer, eval_dashboard, study_design_strands,
  cohort_baseline_comparison
- Update PPT_Figures_Guide and Speaker_Notes for 17-slide flow with cohort
- insert_presentation_figures: embed two-layer on slide 9, add cohort/dashboard/
  coverage/track3 slides
- Sync speaker notes; fix ablation 69% (not 75%)

Co-authored-by: patrickwalsh26 <patrickwalsh26@users.noreply.github.com>
</commit_message>
<xml_diff>
--- a/ADO_powerpoint_presentation.pptx
+++ b/ADO_powerpoint_presentation.pptx
@@ -23,6 +23,10 @@
     <p:sldId id="268" r:id="rId17"/>
     <p:sldId id="269" r:id="rId19"/>
     <p:sldId id="270" r:id="rId20"/>
+    <p:sldId id="271" r:id="rId21"/>
+    <p:sldId id="272" r:id="rId22"/>
+    <p:sldId id="273" r:id="rId23"/>
+    <p:sldId id="274" r:id="rId24"/>
   </p:sldIdLst>
   <p:sldSz cy="6858000" cx="12191675"/>
   <p:notesSz cx="6858000" cy="12191675"/>
@@ -1521,17 +1525,17 @@
           <a:lstStyle/>
           <a:p>
             <a:r>
-              <a:t>NARRATIVE: Act I opens — frame the talk.</a:t>
-            </a:r>
-          </a:p>
-          <a:p>
-            <a:r>
-              <a:t>SAY: Patrick Walsh &amp; Darren Chan. ADO = computable EOL preferences in advanced HF. Not a legal AD — decision support for ACP documentation.</a:t>
-            </a:r>
-          </a:p>
-          <a:p>
-            <a:r>
-              <a:t>TRANSITION: "Start where clinicians live—the 2 a.m. crisis."</a:t>
+              <a:t>NARRATIVE: Act I — frame the talk.</a:t>
+            </a:r>
+          </a:p>
+          <a:p>
+            <a:r>
+              <a:t>SAY: Patrick Walsh &amp; Darren Chan. ADO = computable EOL preferences in advanced HF. Not a legal AD.</a:t>
+            </a:r>
+          </a:p>
+          <a:p>
+            <a:r>
+              <a:t>TRANSITION: "Start at the 2 a.m. crisis."</a:t>
             </a:r>
           </a:p>
           <a:p>
@@ -1683,27 +1687,27 @@
           <a:lstStyle/>
           <a:p>
             <a:r>
-              <a:t>NARRATIVE: Act III — clinical "aha."</a:t>
-            </a:r>
-          </a:p>
-          <a:p>
-            <a:r>
-              <a:t>SAY: Same directive, two scenarios → DNR vs Full code. Flat POLST can't carry if/then.</a:t>
-            </a:r>
-          </a:p>
-          <a:p>
-            <a:r>
-              <a:t>POINT AT: P9/P10 figure if on slide.</a:t>
-            </a:r>
-          </a:p>
-          <a:p>
-            <a:r>
-              <a:t>TRANSITION: "An ethicist placed this in workflow."</a:t>
-            </a:r>
-          </a:p>
-          <a:p>
-            <a:r>
-              <a:t>[~40s]</a:t>
+              <a:t>NARRATIVE: Ablation + conditional aha.</a:t>
+            </a:r>
+          </a:p>
+          <a:p>
+            <a:r>
+              <a:t>SAY: Ablation 11/16 (69%) — activation conditions matter. P9/P10: DNR vs Full code same directive.</a:t>
+            </a:r>
+          </a:p>
+          <a:p>
+            <a:r>
+              <a:t>POINT AT: ablation_conditions.png, conditional_p9_p10.png</a:t>
+            </a:r>
+          </a:p>
+          <a:p>
+            <a:r>
+              <a:t>TRANSITION: "Cohort stress test."</a:t>
+            </a:r>
+          </a:p>
+          <a:p>
+            <a:r>
+              <a:t>[~45s]</a:t>
             </a:r>
           </a:p>
         </p:txBody>
@@ -1850,17 +1854,12 @@
           <a:lstStyle/>
           <a:p>
             <a:r>
-              <a:t>NARRATIVE: Act IV — Magnus reframe.</a:t>
-            </a:r>
-          </a:p>
-          <a:p>
-            <a:r>
-              <a:t>SAY: Not a signed AHCD — ACP progress note. Directive → ADO → ACP pre-pop → conversation → POLST/code status.</a:t>
-            </a:r>
-          </a:p>
-          <a:p>
-            <a:r>
-              <a:t>TRANSITION: "What we didn't solve."</a:t>
+              <a:t>NARRATIVE: Magnus reframe (if slide order = integration before cohort, adjust).</a:t>
+            </a:r>
+          </a:p>
+          <a:p>
+            <a:r>
+              <a:t>SAY: ACP progress note. Directive → ADO → conversation → POLST.</a:t>
             </a:r>
           </a:p>
           <a:p>
@@ -2012,22 +2011,22 @@
           <a:lstStyle/>
           <a:p>
             <a:r>
-              <a:t>NARRATIVE: Act IV — limits without retreating.</a:t>
-            </a:r>
-          </a:p>
-          <a:p>
-            <a:r>
-              <a:t>SAY: No legal force; one-dimensional (who-decides next); coverage gaps; team gold; EHR validation future.</a:t>
-            </a:r>
-          </a:p>
-          <a:p>
-            <a:r>
-              <a:t>TRANSITION: "Four takeaways."</a:t>
-            </a:r>
-          </a:p>
-          <a:p>
-            <a:r>
-              <a:t>[~35s]</a:t>
+              <a:t>NARRATIVE: Limits.</a:t>
+            </a:r>
+          </a:p>
+          <a:p>
+            <a:r>
+              <a:t>SAY: No legal force; cohort oracle not clinical gold; team gold; EHR future.</a:t>
+            </a:r>
+          </a:p>
+          <a:p>
+            <a:r>
+              <a:t>TRANSITION: "Takeaways."</a:t>
+            </a:r>
+          </a:p>
+          <a:p>
+            <a:r>
+              <a:t>[~40s]</a:t>
             </a:r>
           </a:p>
         </p:txBody>
@@ -2179,12 +2178,7 @@
           </a:p>
           <a:p>
             <a:r>
-              <a:t>SAY: Read four bullets. Repo URL. Questions welcome.</a:t>
-            </a:r>
-          </a:p>
-          <a:p>
-            <a:r>
-              <a:t>OFFER: "Happy to run demo scenario 1 live."</a:t>
+              <a:t>SAY: Four bullets. Repo. Questions. Optional demo scenario 1.</a:t>
             </a:r>
           </a:p>
           <a:p>
@@ -2237,6 +2231,421 @@
             <a:endParaRPr/>
           </a:p>
         </p:txBody>
+      </p:sp>
+    </p:spTree>
+  </p:cSld>
+  <p:clrMapOvr>
+    <a:masterClrMapping/>
+  </p:clrMapOvr>
+</p:notes>
+</file>
+
+<file path=ppt/notesSlides/notesSlide14.xml><?xml version="1.0" encoding="utf-8"?>
+<p:notes xmlns:a="http://schemas.openxmlformats.org/drawingml/2006/main" xmlns:p="http://schemas.openxmlformats.org/presentationml/2006/main" xmlns:r="http://schemas.openxmlformats.org/officeDocument/2006/relationships">
+  <p:cSld>
+    <p:spTree>
+      <p:nvGrpSpPr>
+        <p:cNvPr id="1" name=""/>
+        <p:cNvGrpSpPr/>
+        <p:nvPr/>
+      </p:nvGrpSpPr>
+      <p:grpSpPr>
+        <a:xfrm>
+          <a:off x="0" y="0"/>
+          <a:ext cx="0" cy="0"/>
+          <a:chOff x="0" y="0"/>
+          <a:chExt cx="0" cy="0"/>
+        </a:xfrm>
+      </p:grpSpPr>
+      <p:sp>
+        <p:nvSpPr>
+          <p:cNvPr id="2" name="Slide Image Placeholder 1"/>
+          <p:cNvSpPr>
+            <a:spLocks noGrp="1"/>
+          </p:cNvSpPr>
+          <p:nvPr>
+            <p:ph type="sldImg" idx="3"/>
+          </p:nvPr>
+        </p:nvSpPr>
+        <p:spPr/>
+      </p:sp>
+      <p:sp>
+        <p:nvSpPr>
+          <p:cNvPr id="3" name="Notes Placeholder 2"/>
+          <p:cNvSpPr>
+            <a:spLocks noGrp="1"/>
+          </p:cNvSpPr>
+          <p:nvPr>
+            <p:ph type="body" idx="1"/>
+          </p:nvPr>
+        </p:nvSpPr>
+        <p:spPr/>
+        <p:txBody>
+          <a:bodyPr/>
+          <a:lstStyle/>
+          <a:p>
+            <a:r>
+              <a:t>(Legacy slide — prefer COHORT + DASHBOARD slides.)</a:t>
+            </a:r>
+          </a:p>
+          <a:p>
+            <a:r>
+              <a:t>SAY: Lead with ablation 69% and cohort 47%, not only 100% vignettes.</a:t>
+            </a:r>
+          </a:p>
+          <a:p>
+            <a:r>
+              <a:t>[~30s]</a:t>
+            </a:r>
+          </a:p>
+        </p:txBody>
+      </p:sp>
+      <p:sp>
+        <p:nvSpPr>
+          <p:cNvPr id="4" name="Slide Number Placeholder 3"/>
+          <p:cNvSpPr>
+            <a:spLocks noGrp="1"/>
+          </p:cNvSpPr>
+          <p:nvPr>
+            <p:ph type="sldNum" idx="12"/>
+          </p:nvPr>
+        </p:nvSpPr>
+        <p:spPr/>
+      </p:sp>
+    </p:spTree>
+  </p:cSld>
+  <p:clrMapOvr>
+    <a:masterClrMapping/>
+  </p:clrMapOvr>
+</p:notes>
+</file>
+
+<file path=ppt/notesSlides/notesSlide15.xml><?xml version="1.0" encoding="utf-8"?>
+<p:notes xmlns:a="http://schemas.openxmlformats.org/drawingml/2006/main" xmlns:p="http://schemas.openxmlformats.org/presentationml/2006/main" xmlns:r="http://schemas.openxmlformats.org/officeDocument/2006/relationships">
+  <p:cSld>
+    <p:spTree>
+      <p:nvGrpSpPr>
+        <p:cNvPr id="1" name=""/>
+        <p:cNvGrpSpPr/>
+        <p:nvPr/>
+      </p:nvGrpSpPr>
+      <p:grpSpPr>
+        <a:xfrm>
+          <a:off x="0" y="0"/>
+          <a:ext cx="0" cy="0"/>
+          <a:chOff x="0" y="0"/>
+          <a:chExt cx="0" cy="0"/>
+        </a:xfrm>
+      </p:grpSpPr>
+      <p:sp>
+        <p:nvSpPr>
+          <p:cNvPr id="2" name="Slide Image Placeholder 1"/>
+          <p:cNvSpPr>
+            <a:spLocks noGrp="1"/>
+          </p:cNvSpPr>
+          <p:nvPr>
+            <p:ph type="sldImg" idx="3"/>
+          </p:nvPr>
+        </p:nvSpPr>
+        <p:spPr/>
+      </p:sp>
+      <p:sp>
+        <p:nvSpPr>
+          <p:cNvPr id="3" name="Notes Placeholder 2"/>
+          <p:cNvSpPr>
+            <a:spLocks noGrp="1"/>
+          </p:cNvSpPr>
+          <p:nvPr>
+            <p:ph type="body" idx="1"/>
+          </p:nvPr>
+        </p:nvSpPr>
+        <p:spPr/>
+        <p:txBody>
+          <a:bodyPr/>
+          <a:lstStyle/>
+          <a:p>
+            <a:r>
+              <a:t>NARRATIVE: Cohort honesty slide.</a:t>
+            </a:r>
+          </a:p>
+          <a:p>
+            <a:r>
+              <a:t>SAY: 20 profiles (messy_level tags) × 12 scenarios = 520 cells. ~47% vs simplified oracle. 421/520 checkbox overconfident. Clean &gt; minimal/contradictory.</a:t>
+            </a:r>
+          </a:p>
+          <a:p>
+            <a:r>
+              <a:t>POINT AT: cohort_messy_breakdown.png, cohort_baseline_comparison.png</a:t>
+            </a:r>
+          </a:p>
+          <a:p>
+            <a:r>
+              <a:t>[~50s]</a:t>
+            </a:r>
+          </a:p>
+        </p:txBody>
+      </p:sp>
+      <p:sp>
+        <p:nvSpPr>
+          <p:cNvPr id="4" name="Slide Number Placeholder 3"/>
+          <p:cNvSpPr>
+            <a:spLocks noGrp="1"/>
+          </p:cNvSpPr>
+          <p:nvPr>
+            <p:ph type="sldNum" idx="12"/>
+          </p:nvPr>
+        </p:nvSpPr>
+        <p:spPr/>
+      </p:sp>
+    </p:spTree>
+  </p:cSld>
+  <p:clrMapOvr>
+    <a:masterClrMapping/>
+  </p:clrMapOvr>
+</p:notes>
+</file>
+
+<file path=ppt/notesSlides/notesSlide16.xml><?xml version="1.0" encoding="utf-8"?>
+<p:notes xmlns:a="http://schemas.openxmlformats.org/drawingml/2006/main" xmlns:p="http://schemas.openxmlformats.org/presentationml/2006/main" xmlns:r="http://schemas.openxmlformats.org/officeDocument/2006/relationships">
+  <p:cSld>
+    <p:spTree>
+      <p:nvGrpSpPr>
+        <p:cNvPr id="1" name=""/>
+        <p:cNvGrpSpPr/>
+        <p:nvPr/>
+      </p:nvGrpSpPr>
+      <p:grpSpPr>
+        <a:xfrm>
+          <a:off x="0" y="0"/>
+          <a:ext cx="0" cy="0"/>
+          <a:chOff x="0" y="0"/>
+          <a:chExt cx="0" cy="0"/>
+        </a:xfrm>
+      </p:grpSpPr>
+      <p:sp>
+        <p:nvSpPr>
+          <p:cNvPr id="2" name="Slide Image Placeholder 1"/>
+          <p:cNvSpPr>
+            <a:spLocks noGrp="1"/>
+          </p:cNvSpPr>
+          <p:nvPr>
+            <p:ph type="sldImg" idx="3"/>
+          </p:nvPr>
+        </p:nvSpPr>
+        <p:spPr/>
+      </p:sp>
+      <p:sp>
+        <p:nvSpPr>
+          <p:cNvPr id="3" name="Notes Placeholder 2"/>
+          <p:cNvSpPr>
+            <a:spLocks noGrp="1"/>
+          </p:cNvSpPr>
+          <p:nvPr>
+            <p:ph type="body" idx="1"/>
+          </p:nvPr>
+        </p:nvSpPr>
+        <p:spPr/>
+        <p:txBody>
+          <a:bodyPr/>
+          <a:lstStyle/>
+          <a:p>
+            <a:r>
+              <a:t>NARRATIVE: Backup all-in-one numbers.</a:t>
+            </a:r>
+          </a:p>
+          <a:p>
+            <a:r>
+              <a:t>SAY: Walk six panels if asked for full summary. Optional — skip if short on time.</a:t>
+            </a:r>
+          </a:p>
+          <a:p>
+            <a:r>
+              <a:t>[~20s]</a:t>
+            </a:r>
+          </a:p>
+        </p:txBody>
+      </p:sp>
+      <p:sp>
+        <p:nvSpPr>
+          <p:cNvPr id="4" name="Slide Number Placeholder 3"/>
+          <p:cNvSpPr>
+            <a:spLocks noGrp="1"/>
+          </p:cNvSpPr>
+          <p:nvPr>
+            <p:ph type="sldNum" idx="12"/>
+          </p:nvPr>
+        </p:nvSpPr>
+        <p:spPr/>
+      </p:sp>
+    </p:spTree>
+  </p:cSld>
+  <p:clrMapOvr>
+    <a:masterClrMapping/>
+  </p:clrMapOvr>
+</p:notes>
+</file>
+
+<file path=ppt/notesSlides/notesSlide17.xml><?xml version="1.0" encoding="utf-8"?>
+<p:notes xmlns:a="http://schemas.openxmlformats.org/drawingml/2006/main" xmlns:p="http://schemas.openxmlformats.org/presentationml/2006/main" xmlns:r="http://schemas.openxmlformats.org/officeDocument/2006/relationships">
+  <p:cSld>
+    <p:spTree>
+      <p:nvGrpSpPr>
+        <p:cNvPr id="1" name=""/>
+        <p:cNvGrpSpPr/>
+        <p:nvPr/>
+      </p:nvGrpSpPr>
+      <p:grpSpPr>
+        <a:xfrm>
+          <a:off x="0" y="0"/>
+          <a:ext cx="0" cy="0"/>
+          <a:chOff x="0" y="0"/>
+          <a:chExt cx="0" cy="0"/>
+        </a:xfrm>
+      </p:grpSpPr>
+      <p:sp>
+        <p:nvSpPr>
+          <p:cNvPr id="2" name="Slide Image Placeholder 1"/>
+          <p:cNvSpPr>
+            <a:spLocks noGrp="1"/>
+          </p:cNvSpPr>
+          <p:nvPr>
+            <p:ph type="sldImg" idx="3"/>
+          </p:nvPr>
+        </p:nvSpPr>
+        <p:spPr/>
+      </p:sp>
+      <p:sp>
+        <p:nvSpPr>
+          <p:cNvPr id="3" name="Notes Placeholder 2"/>
+          <p:cNvSpPr>
+            <a:spLocks noGrp="1"/>
+          </p:cNvSpPr>
+          <p:nvPr>
+            <p:ph type="body" idx="1"/>
+          </p:nvPr>
+        </p:nvSpPr>
+        <p:spPr/>
+        <p:txBody>
+          <a:bodyPr/>
+          <a:lstStyle/>
+          <a:p>
+            <a:r>
+              <a:t>NARRATIVE: Scope + extraction discipline.</a:t>
+            </a:r>
+          </a:p>
+          <a:p>
+            <a:r>
+              <a:t>SAY: 47% fully representable (14/30). F1 0.97, 0 OOS hallucinations on nutrition/antibiotics.</a:t>
+            </a:r>
+          </a:p>
+          <a:p>
+            <a:r>
+              <a:t>POINT AT: coverage_inventory.png, extraction_f1.png</a:t>
+            </a:r>
+          </a:p>
+          <a:p>
+            <a:r>
+              <a:t>[~35s]</a:t>
+            </a:r>
+          </a:p>
+        </p:txBody>
+      </p:sp>
+      <p:sp>
+        <p:nvSpPr>
+          <p:cNvPr id="4" name="Slide Number Placeholder 3"/>
+          <p:cNvSpPr>
+            <a:spLocks noGrp="1"/>
+          </p:cNvSpPr>
+          <p:nvPr>
+            <p:ph type="sldNum" idx="12"/>
+          </p:nvPr>
+        </p:nvSpPr>
+        <p:spPr/>
+      </p:sp>
+    </p:spTree>
+  </p:cSld>
+  <p:clrMapOvr>
+    <a:masterClrMapping/>
+  </p:clrMapOvr>
+</p:notes>
+</file>
+
+<file path=ppt/notesSlides/notesSlide18.xml><?xml version="1.0" encoding="utf-8"?>
+<p:notes xmlns:a="http://schemas.openxmlformats.org/drawingml/2006/main" xmlns:p="http://schemas.openxmlformats.org/presentationml/2006/main" xmlns:r="http://schemas.openxmlformats.org/officeDocument/2006/relationships">
+  <p:cSld>
+    <p:spTree>
+      <p:nvGrpSpPr>
+        <p:cNvPr id="1" name=""/>
+        <p:cNvGrpSpPr/>
+        <p:nvPr/>
+      </p:nvGrpSpPr>
+      <p:grpSpPr>
+        <a:xfrm>
+          <a:off x="0" y="0"/>
+          <a:ext cx="0" cy="0"/>
+          <a:chOff x="0" y="0"/>
+          <a:chExt cx="0" cy="0"/>
+        </a:xfrm>
+      </p:grpSpPr>
+      <p:sp>
+        <p:nvSpPr>
+          <p:cNvPr id="2" name="Slide Image Placeholder 1"/>
+          <p:cNvSpPr>
+            <a:spLocks noGrp="1"/>
+          </p:cNvSpPr>
+          <p:nvPr>
+            <p:ph type="sldImg" idx="3"/>
+          </p:nvPr>
+        </p:nvSpPr>
+        <p:spPr/>
+      </p:sp>
+      <p:sp>
+        <p:nvSpPr>
+          <p:cNvPr id="3" name="Notes Placeholder 2"/>
+          <p:cNvSpPr>
+            <a:spLocks noGrp="1"/>
+          </p:cNvSpPr>
+          <p:nvPr>
+            <p:ph type="body" idx="1"/>
+          </p:nvPr>
+        </p:nvSpPr>
+        <p:spPr/>
+        <p:txBody>
+          <a:bodyPr/>
+          <a:lstStyle/>
+          <a:p>
+            <a:r>
+              <a:t>NARRATIVE: Bedside mapping.</a:t>
+            </a:r>
+          </a:p>
+          <a:p>
+            <a:r>
+              <a:t>SAY: 35/36 fields. P5 principled divergence. Confusion matrix diagonal.</a:t>
+            </a:r>
+          </a:p>
+          <a:p>
+            <a:r>
+              <a:t>POINT AT: track3_field_agreement.png, code_status_confusion.png</a:t>
+            </a:r>
+          </a:p>
+          <a:p>
+            <a:r>
+              <a:t>[~35s]</a:t>
+            </a:r>
+          </a:p>
+        </p:txBody>
+      </p:sp>
+      <p:sp>
+        <p:nvSpPr>
+          <p:cNvPr id="4" name="Slide Number Placeholder 3"/>
+          <p:cNvSpPr>
+            <a:spLocks noGrp="1"/>
+          </p:cNvSpPr>
+          <p:nvPr>
+            <p:ph type="sldNum" idx="12"/>
+          </p:nvPr>
+        </p:nvSpPr>
+        <p:spPr/>
       </p:sp>
     </p:spTree>
   </p:cSld>
@@ -2341,17 +2750,12 @@
           </a:p>
           <a:p>
             <a:r>
-              <a:t>SAY: AD → POLST → code status. Loss = conditional wishes → coarse boxes. "Free text" cliché is half wrong—CA/UC forms are checkboxes. Real problem: low resolution + disease blindness.</a:t>
-            </a:r>
-          </a:p>
-          <a:p>
-            <a:r>
-              <a:t>POINT AT: ventilator example on slide.</a:t>
-            </a:r>
-          </a:p>
-          <a:p>
-            <a:r>
-              <a:t>TRANSITION: "HF is where that blindness hurts most."</a:t>
+              <a:t>SAY: AD → POLST → code status. Conditional wishes → coarse boxes. Low resolution + disease blindness.</a:t>
+            </a:r>
+          </a:p>
+          <a:p>
+            <a:r>
+              <a:t>TRANSITION: "HF is where that hurts most."</a:t>
             </a:r>
           </a:p>
           <a:p>
@@ -2508,12 +2912,12 @@
           </a:p>
           <a:p>
             <a:r>
-              <a:t>SAY: Unpredictable, device-heavy, repeated ED/ICU visits. Five decision points. ICD/LVAD/inotropes missing from generic templates.</a:t>
-            </a:r>
-          </a:p>
-          <a:p>
-            <a:r>
-              <a:t>TRANSITION: "What's the smallest object that preserves patient logic?"</a:t>
+              <a:t>SAY: Five decision points. ICD/LVAD/inotropes missing from generic templates.</a:t>
+            </a:r>
+          </a:p>
+          <a:p>
+            <a:r>
+              <a:t>TRANSITION: "Smallest object that preserves patient logic?"</a:t>
             </a:r>
           </a:p>
           <a:p>
@@ -2665,17 +3069,17 @@
           <a:lstStyle/>
           <a:p>
             <a:r>
-              <a:t>NARRATIVE: Act II begins — PreferenceStatement.</a:t>
-            </a:r>
-          </a:p>
-          <a:p>
-            <a:r>
-              <a:t>SAY: Intervention + activation conditions + strength + negation + verbatim text. Reasoner asks: does this apply in THIS scenario? Walk 72h vasopressor example.</a:t>
-            </a:r>
-          </a:p>
-          <a:p>
-            <a:r>
-              <a:t>TRANSITION: "How much structure we built around that."</a:t>
+              <a:t>NARRATIVE: Act II — PreferenceStatement.</a:t>
+            </a:r>
+          </a:p>
+          <a:p>
+            <a:r>
+              <a:t>SAY: Intervention + activation + strength + negation + verbatim. Walk 72h vasopressor example.</a:t>
+            </a:r>
+          </a:p>
+          <a:p>
+            <a:r>
+              <a:t>TRANSITION: "How much structure we built."</a:t>
             </a:r>
           </a:p>
           <a:p>
@@ -2832,22 +3236,22 @@
           </a:p>
           <a:p>
             <a:r>
-              <a:t>SAY: 67 classes, 22 properties, 21 interventions—finer than our 50-form inventory. SNOMED where possible.</a:t>
-            </a:r>
-          </a:p>
-          <a:p>
-            <a:r>
-              <a:t>OPTIONAL LIVE: Open Protégé → ado_jane_doe_001.owl → expand Intervention tree (see Protege_Showcase_Guide.md). POINT AT hierarchy figure on slide.</a:t>
-            </a:r>
-          </a:p>
-          <a:p>
-            <a:r>
-              <a:t>TRANSITION: "Granularity only helps if we know when NOT to answer."</a:t>
-            </a:r>
-          </a:p>
-          <a:p>
-            <a:r>
-              <a:t>[~35s, +2 min if Protégé live]</a:t>
+              <a:t>SAY: 67 classes, 22 properties, 21 interventions. POINT AT hierarchy figure.</a:t>
+            </a:r>
+          </a:p>
+          <a:p>
+            <a:r>
+              <a:t>OPTIONAL LIVE: Protégé — ado_jane_doe_001.owl</a:t>
+            </a:r>
+          </a:p>
+          <a:p>
+            <a:r>
+              <a:t>TRANSITION: "Know when NOT to answer."</a:t>
+            </a:r>
+          </a:p>
+          <a:p>
+            <a:r>
+              <a:t>[~35s]</a:t>
             </a:r>
           </a:p>
         </p:txBody>
@@ -2994,17 +3398,17 @@
           <a:lstStyle/>
           <a:p>
             <a:r>
-              <a:t>NARRATIVE: Act II — safety thesis (four honest outputs).</a:t>
-            </a:r>
-          </a:p>
-          <a:p>
-            <a:r>
-              <a:t>SAY: Clear / Partial / No coverage / Vague. Punchline: checkbox or LLM can't say "I don't know." ADO can.</a:t>
-            </a:r>
-          </a:p>
-          <a:p>
-            <a:r>
-              <a:t>TRANSITION: "How we wired that into a pipeline."</a:t>
+              <a:t>NARRATIVE: Act II — four honest outputs.</a:t>
+            </a:r>
+          </a:p>
+          <a:p>
+            <a:r>
+              <a:t>SAY: Clear / Partial / No coverage / Vague. Can't say "I don't know" = safety failure.</a:t>
+            </a:r>
+          </a:p>
+          <a:p>
+            <a:r>
+              <a:t>TRANSITION: "Pipeline wiring."</a:t>
             </a:r>
           </a:p>
           <a:p>
@@ -3161,17 +3565,12 @@
           </a:p>
           <a:p>
             <a:r>
-              <a:t>SAY: LLMs extract ONLY. Ontology = auditable truth. Reasoner decides. Closed-world: out-of-scope → extract nothing. Tagline: WITH LLMs, not vs.</a:t>
-            </a:r>
-          </a:p>
-          <a:p>
-            <a:r>
-              <a:t>OPTIONAL: "We can demo scenario 1 live after results."</a:t>
-            </a:r>
-          </a:p>
-          <a:p>
-            <a:r>
-              <a:t>TRANSITION: "We tested that three ways."</a:t>
+              <a:t>SAY: LLMs extract ONLY. Ontology = truth. Reasoner decides. Closed-world extraction.</a:t>
+            </a:r>
+          </a:p>
+          <a:p>
+            <a:r>
+              <a:t>TRANSITION: "Six evaluation strands including 520-cell cohort."</a:t>
             </a:r>
           </a:p>
           <a:p>
@@ -3323,27 +3722,27 @@
           <a:lstStyle/>
           <a:p>
             <a:r>
-              <a:t>NARRATIVE: Act III — earn trust before numbers.</a:t>
-            </a:r>
-          </a:p>
-          <a:p>
-            <a:r>
-              <a:t>SAY: 5 evaluation strands on slide. Caveat: team gold, grounded in real templates + POLST semantics. Ablation = same 16 vignettes without conditions → 75%.</a:t>
-            </a:r>
-          </a:p>
-          <a:p>
-            <a:r>
-              <a:t>POINT AT: vignette pie chart (if visible).</a:t>
-            </a:r>
-          </a:p>
-          <a:p>
-            <a:r>
-              <a:t>TRANSITION: "Here's what we found."</a:t>
-            </a:r>
-          </a:p>
-          <a:p>
-            <a:r>
-              <a:t>[~45s]</a:t>
+              <a:t>NARRATIVE: Act III — study design (six strands).</a:t>
+            </a:r>
+          </a:p>
+          <a:p>
+            <a:r>
+              <a:t>SAY: Vignettes 16+10 held-out; ablation; cohort 520 cells (20×12); extraction n=12; POLST n=12; coverage 30 clauses. Developmental — not clinical trial.</a:t>
+            </a:r>
+          </a:p>
+          <a:p>
+            <a:r>
+              <a:t>POINT AT: study_design_strands.png</a:t>
+            </a:r>
+          </a:p>
+          <a:p>
+            <a:r>
+              <a:t>TRANSITION: "Two-layer validation."</a:t>
+            </a:r>
+          </a:p>
+          <a:p>
+            <a:r>
+              <a:t>[~50s]</a:t>
             </a:r>
           </a:p>
         </p:txBody>
@@ -3490,27 +3889,27 @@
           <a:lstStyle/>
           <a:p>
             <a:r>
-              <a:t>NARRATIVE: Act III — flagship results.</a:t>
-            </a:r>
-          </a:p>
-          <a:p>
-            <a:r>
-              <a:t>SAY: Track 1: 16/16. Track 2: F1 0.97, 0 hallucinations on nutrition/antibiotics. Track 3: 35/36 (97%), κ 1.00/1.00/0.88. Ablation: 75% without conditions = 4 false-confident conditional errors.</a:t>
-            </a:r>
-          </a:p>
-          <a:p>
-            <a:r>
-              <a:t>POINT AT: bar charts on right of slide.</a:t>
-            </a:r>
-          </a:p>
-          <a:p>
-            <a:r>
-              <a:t>TRANSITION: "One profile pair shows the clinical payoff."</a:t>
-            </a:r>
-          </a:p>
-          <a:p>
-            <a:r>
-              <a:t>[~55s]</a:t>
+              <a:t>NARRATIVE: Act III — MAIN RESULTS (two-layer).</a:t>
+            </a:r>
+          </a:p>
+          <a:p>
+            <a:r>
+              <a:t>SAY: Layer 1: 16/16 dev, 10/10 held-out, 69% ablation — spec test on Jane Doe. Layer 2: cohort ~47% vs simplified oracle; checkbox fails nuanced cells. Also F1 0.97, 35/36 POLST.</a:t>
+            </a:r>
+          </a:p>
+          <a:p>
+            <a:r>
+              <a:t>POINT AT: eval_two_layer.png (full slide). DO NOT oversell 100%.</a:t>
+            </a:r>
+          </a:p>
+          <a:p>
+            <a:r>
+              <a:t>TRANSITION: "Conditionality + cohort detail."</a:t>
+            </a:r>
+          </a:p>
+          <a:p>
+            <a:r>
+              <a:t>[~60s]</a:t>
             </a:r>
           </a:p>
         </p:txBody>
@@ -6021,6 +6420,54 @@
           </a:prstGeom>
         </p:spPr>
       </p:pic>
+      <p:pic>
+        <p:nvPicPr>
+          <p:cNvPr id="241" name="Picture 240" descr="conditional_p9_p10.png"/>
+          <p:cNvPicPr>
+            <a:picLocks noChangeAspect="1"/>
+          </p:cNvPicPr>
+          <p:nvPr/>
+        </p:nvPicPr>
+        <p:blipFill>
+          <a:blip r:embed="rId4"/>
+          <a:stretch>
+            <a:fillRect/>
+          </a:stretch>
+        </p:blipFill>
+        <p:spPr>
+          <a:xfrm>
+            <a:off x="6217920" y="1234440"/>
+            <a:ext cx="5486400" cy="2847962"/>
+          </a:xfrm>
+          <a:prstGeom prst="rect">
+            <a:avLst/>
+          </a:prstGeom>
+        </p:spPr>
+      </p:pic>
+      <p:pic>
+        <p:nvPicPr>
+          <p:cNvPr id="242" name="Picture 241" descr="ablation_conditions.png"/>
+          <p:cNvPicPr>
+            <a:picLocks noChangeAspect="1"/>
+          </p:cNvPicPr>
+          <p:nvPr/>
+        </p:nvPicPr>
+        <p:blipFill>
+          <a:blip r:embed="rId5"/>
+          <a:stretch>
+            <a:fillRect/>
+          </a:stretch>
+        </p:blipFill>
+        <p:spPr>
+          <a:xfrm>
+            <a:off x="320040" y="1234440"/>
+            <a:ext cx="5029200" cy="3369371"/>
+          </a:xfrm>
+          <a:prstGeom prst="rect">
+            <a:avLst/>
+          </a:prstGeom>
+        </p:spPr>
+      </p:pic>
     </p:spTree>
   </p:cSld>
   <p:clrMapOvr>
@@ -9369,6 +9816,425 @@
 </p:sld>
 </file>
 
+<file path=ppt/slides/slide16.xml><?xml version="1.0" encoding="utf-8"?>
+<p:sld xmlns:a="http://schemas.openxmlformats.org/drawingml/2006/main" xmlns:p="http://schemas.openxmlformats.org/presentationml/2006/main" xmlns:r="http://schemas.openxmlformats.org/officeDocument/2006/relationships">
+  <p:cSld>
+    <p:spTree>
+      <p:nvGrpSpPr>
+        <p:cNvPr id="1" name=""/>
+        <p:cNvGrpSpPr/>
+        <p:nvPr/>
+      </p:nvGrpSpPr>
+      <p:grpSpPr/>
+      <p:sp>
+        <p:nvSpPr>
+          <p:cNvPr id="2" name="TextBox 1"/>
+          <p:cNvSpPr txBox="1"/>
+          <p:nvPr/>
+        </p:nvSpPr>
+        <p:spPr>
+          <a:xfrm>
+            <a:off x="365760" y="201168"/>
+            <a:ext cx="11430000" cy="502920"/>
+          </a:xfrm>
+          <a:prstGeom prst="rect">
+            <a:avLst/>
+          </a:prstGeom>
+          <a:noFill/>
+        </p:spPr>
+        <p:txBody>
+          <a:bodyPr wrap="none">
+            <a:spAutoFit/>
+          </a:bodyPr>
+          <a:lstStyle/>
+          <a:p>
+            <a:pPr>
+              <a:defRPr sz="1700" b="1"/>
+            </a:pPr>
+            <a:r>
+              <a:t>COHORT STRESS TEST — 20 messy profiles × 12 scenarios (520 cells)</a:t>
+            </a:r>
+          </a:p>
+        </p:txBody>
+      </p:sp>
+      <p:pic>
+        <p:nvPicPr>
+          <p:cNvPr id="3" name="Picture 2" descr="cohort_messy_breakdown.png"/>
+          <p:cNvPicPr>
+            <a:picLocks noChangeAspect="1"/>
+          </p:cNvPicPr>
+          <p:nvPr/>
+        </p:nvPicPr>
+        <p:blipFill>
+          <a:blip r:embed="rId2"/>
+          <a:stretch>
+            <a:fillRect/>
+          </a:stretch>
+        </p:blipFill>
+        <p:spPr>
+          <a:xfrm>
+            <a:off x="320040" y="868680"/>
+            <a:ext cx="5669280" cy="2778182"/>
+          </a:xfrm>
+          <a:prstGeom prst="rect">
+            <a:avLst/>
+          </a:prstGeom>
+        </p:spPr>
+      </p:pic>
+      <p:pic>
+        <p:nvPicPr>
+          <p:cNvPr id="4" name="Picture 3" descr="cohort_baseline_comparison.png"/>
+          <p:cNvPicPr>
+            <a:picLocks noChangeAspect="1"/>
+          </p:cNvPicPr>
+          <p:nvPr/>
+        </p:nvPicPr>
+        <p:blipFill>
+          <a:blip r:embed="rId3"/>
+          <a:stretch>
+            <a:fillRect/>
+          </a:stretch>
+        </p:blipFill>
+        <p:spPr>
+          <a:xfrm>
+            <a:off x="6080760" y="868680"/>
+            <a:ext cx="5669280" cy="2353115"/>
+          </a:xfrm>
+          <a:prstGeom prst="rect">
+            <a:avLst/>
+          </a:prstGeom>
+        </p:spPr>
+      </p:pic>
+      <p:sp>
+        <p:nvSpPr>
+          <p:cNvPr id="5" name="TextBox 4"/>
+          <p:cNvSpPr txBox="1"/>
+          <p:nvPr/>
+        </p:nvSpPr>
+        <p:spPr>
+          <a:xfrm>
+            <a:off x="365760" y="5989320"/>
+            <a:ext cx="11247120" cy="502920"/>
+          </a:xfrm>
+          <a:prstGeom prst="rect">
+            <a:avLst/>
+          </a:prstGeom>
+          <a:noFill/>
+        </p:spPr>
+        <p:txBody>
+          <a:bodyPr wrap="none">
+            <a:spAutoFit/>
+          </a:bodyPr>
+          <a:lstStyle/>
+          <a:p>
+            <a:pPr>
+              <a:defRPr sz="1100"/>
+            </a:pPr>
+            <a:r>
+              <a:t>~47% agreement vs simplified reference oracle (not hand-adjudicated). Flat checkbox over-asserts on 421/520 nuanced cells. Honest population stress test — complements 16/16 vignette spec test.</a:t>
+            </a:r>
+          </a:p>
+        </p:txBody>
+      </p:sp>
+    </p:spTree>
+  </p:cSld>
+  <p:clrMapOvr>
+    <a:masterClrMapping/>
+  </p:clrMapOvr>
+</p:sld>
+</file>
+
+<file path=ppt/slides/slide17.xml><?xml version="1.0" encoding="utf-8"?>
+<p:sld xmlns:a="http://schemas.openxmlformats.org/drawingml/2006/main" xmlns:p="http://schemas.openxmlformats.org/presentationml/2006/main" xmlns:r="http://schemas.openxmlformats.org/officeDocument/2006/relationships">
+  <p:cSld>
+    <p:spTree>
+      <p:nvGrpSpPr>
+        <p:cNvPr id="1" name=""/>
+        <p:cNvGrpSpPr/>
+        <p:nvPr/>
+      </p:nvGrpSpPr>
+      <p:grpSpPr/>
+      <p:sp>
+        <p:nvSpPr>
+          <p:cNvPr id="2" name="TextBox 1"/>
+          <p:cNvSpPr txBox="1"/>
+          <p:nvPr/>
+        </p:nvSpPr>
+        <p:spPr>
+          <a:xfrm>
+            <a:off x="365760" y="182880"/>
+            <a:ext cx="11430000" cy="457200"/>
+          </a:xfrm>
+          <a:prstGeom prst="rect">
+            <a:avLst/>
+          </a:prstGeom>
+          <a:noFill/>
+        </p:spPr>
+        <p:txBody>
+          <a:bodyPr wrap="none">
+            <a:spAutoFit/>
+          </a:bodyPr>
+          <a:lstStyle/>
+          <a:p>
+            <a:pPr>
+              <a:defRPr sz="1700" b="1"/>
+            </a:pPr>
+            <a:r>
+              <a:t>EVALUATION DASHBOARD — developmental validation (June 2026)</a:t>
+            </a:r>
+          </a:p>
+        </p:txBody>
+      </p:sp>
+      <p:pic>
+        <p:nvPicPr>
+          <p:cNvPr id="3" name="Picture 2" descr="eval_dashboard.png"/>
+          <p:cNvPicPr>
+            <a:picLocks noChangeAspect="1"/>
+          </p:cNvPicPr>
+          <p:nvPr/>
+        </p:nvPicPr>
+        <p:blipFill>
+          <a:blip r:embed="rId2"/>
+          <a:stretch>
+            <a:fillRect/>
+          </a:stretch>
+        </p:blipFill>
+        <p:spPr>
+          <a:xfrm>
+            <a:off x="274320" y="685800"/>
+            <a:ext cx="11521440" cy="7424760"/>
+          </a:xfrm>
+          <a:prstGeom prst="rect">
+            <a:avLst/>
+          </a:prstGeom>
+        </p:spPr>
+      </p:pic>
+    </p:spTree>
+  </p:cSld>
+  <p:clrMapOvr>
+    <a:masterClrMapping/>
+  </p:clrMapOvr>
+</p:sld>
+</file>
+
+<file path=ppt/slides/slide18.xml><?xml version="1.0" encoding="utf-8"?>
+<p:sld xmlns:a="http://schemas.openxmlformats.org/drawingml/2006/main" xmlns:p="http://schemas.openxmlformats.org/presentationml/2006/main" xmlns:r="http://schemas.openxmlformats.org/officeDocument/2006/relationships">
+  <p:cSld>
+    <p:spTree>
+      <p:nvGrpSpPr>
+        <p:cNvPr id="1" name=""/>
+        <p:cNvGrpSpPr/>
+        <p:nvPr/>
+      </p:nvGrpSpPr>
+      <p:grpSpPr/>
+      <p:sp>
+        <p:nvSpPr>
+          <p:cNvPr id="2" name="TextBox 1"/>
+          <p:cNvSpPr txBox="1"/>
+          <p:nvPr/>
+        </p:nvSpPr>
+        <p:spPr>
+          <a:xfrm>
+            <a:off x="365760" y="201168"/>
+            <a:ext cx="11430000" cy="457200"/>
+          </a:xfrm>
+          <a:prstGeom prst="rect">
+            <a:avLst/>
+          </a:prstGeom>
+          <a:noFill/>
+        </p:spPr>
+        <p:txBody>
+          <a:bodyPr wrap="none">
+            <a:spAutoFit/>
+          </a:bodyPr>
+          <a:lstStyle/>
+          <a:p>
+            <a:pPr>
+              <a:defRPr b="1" sz="1700"/>
+            </a:pPr>
+            <a:r>
+              <a:t>COVERAGE &amp; EXTRACTION — scope and closed-world discipline</a:t>
+            </a:r>
+          </a:p>
+        </p:txBody>
+      </p:sp>
+      <p:pic>
+        <p:nvPicPr>
+          <p:cNvPr id="3" name="Picture 2" descr="coverage_inventory.png"/>
+          <p:cNvPicPr>
+            <a:picLocks noChangeAspect="1"/>
+          </p:cNvPicPr>
+          <p:nvPr/>
+        </p:nvPicPr>
+        <p:blipFill>
+          <a:blip r:embed="rId2"/>
+          <a:stretch>
+            <a:fillRect/>
+          </a:stretch>
+        </p:blipFill>
+        <p:spPr>
+          <a:xfrm>
+            <a:off x="320040" y="868680"/>
+            <a:ext cx="5760720" cy="2922803"/>
+          </a:xfrm>
+          <a:prstGeom prst="rect">
+            <a:avLst/>
+          </a:prstGeom>
+        </p:spPr>
+      </p:pic>
+      <p:pic>
+        <p:nvPicPr>
+          <p:cNvPr id="4" name="Picture 3" descr="extraction_f1.png"/>
+          <p:cNvPicPr>
+            <a:picLocks noChangeAspect="1"/>
+          </p:cNvPicPr>
+          <p:nvPr/>
+        </p:nvPicPr>
+        <p:blipFill>
+          <a:blip r:embed="rId3"/>
+          <a:stretch>
+            <a:fillRect/>
+          </a:stretch>
+        </p:blipFill>
+        <p:spPr>
+          <a:xfrm>
+            <a:off x="6172200" y="1005840"/>
+            <a:ext cx="5303520" cy="3381322"/>
+          </a:xfrm>
+          <a:prstGeom prst="rect">
+            <a:avLst/>
+          </a:prstGeom>
+        </p:spPr>
+      </p:pic>
+      <p:pic>
+        <p:nvPicPr>
+          <p:cNvPr id="5" name="Picture 4" descr="vignette_splits.png"/>
+          <p:cNvPicPr>
+            <a:picLocks noChangeAspect="1"/>
+          </p:cNvPicPr>
+          <p:nvPr/>
+        </p:nvPicPr>
+        <p:blipFill>
+          <a:blip r:embed="rId4"/>
+          <a:stretch>
+            <a:fillRect/>
+          </a:stretch>
+        </p:blipFill>
+        <p:spPr>
+          <a:xfrm>
+            <a:off x="6172200" y="3657600"/>
+            <a:ext cx="5303520" cy="3803818"/>
+          </a:xfrm>
+          <a:prstGeom prst="rect">
+            <a:avLst/>
+          </a:prstGeom>
+        </p:spPr>
+      </p:pic>
+    </p:spTree>
+  </p:cSld>
+  <p:clrMapOvr>
+    <a:masterClrMapping/>
+  </p:clrMapOvr>
+</p:sld>
+</file>
+
+<file path=ppt/slides/slide19.xml><?xml version="1.0" encoding="utf-8"?>
+<p:sld xmlns:a="http://schemas.openxmlformats.org/drawingml/2006/main" xmlns:p="http://schemas.openxmlformats.org/presentationml/2006/main" xmlns:r="http://schemas.openxmlformats.org/officeDocument/2006/relationships">
+  <p:cSld>
+    <p:spTree>
+      <p:nvGrpSpPr>
+        <p:cNvPr id="1" name=""/>
+        <p:cNvGrpSpPr/>
+        <p:nvPr/>
+      </p:nvGrpSpPr>
+      <p:grpSpPr/>
+      <p:sp>
+        <p:nvSpPr>
+          <p:cNvPr id="2" name="TextBox 1"/>
+          <p:cNvSpPr txBox="1"/>
+          <p:nvPr/>
+        </p:nvSpPr>
+        <p:spPr>
+          <a:xfrm>
+            <a:off x="365760" y="201168"/>
+            <a:ext cx="10972800" cy="457200"/>
+          </a:xfrm>
+          <a:prstGeom prst="rect">
+            <a:avLst/>
+          </a:prstGeom>
+          <a:noFill/>
+        </p:spPr>
+        <p:txBody>
+          <a:bodyPr wrap="none">
+            <a:spAutoFit/>
+          </a:bodyPr>
+          <a:lstStyle/>
+          <a:p>
+            <a:pPr>
+              <a:defRPr b="1" sz="1700"/>
+            </a:pPr>
+            <a:r>
+              <a:t>TRACK 3 — CODE STATUS &amp; POLST MAPPING</a:t>
+            </a:r>
+          </a:p>
+        </p:txBody>
+      </p:sp>
+      <p:pic>
+        <p:nvPicPr>
+          <p:cNvPr id="3" name="Picture 2" descr="track3_field_agreement.png"/>
+          <p:cNvPicPr>
+            <a:picLocks noChangeAspect="1"/>
+          </p:cNvPicPr>
+          <p:nvPr/>
+        </p:nvPicPr>
+        <p:blipFill>
+          <a:blip r:embed="rId2"/>
+          <a:stretch>
+            <a:fillRect/>
+          </a:stretch>
+        </p:blipFill>
+        <p:spPr>
+          <a:xfrm>
+            <a:off x="320040" y="868680"/>
+            <a:ext cx="5577840" cy="2957395"/>
+          </a:xfrm>
+          <a:prstGeom prst="rect">
+            <a:avLst/>
+          </a:prstGeom>
+        </p:spPr>
+      </p:pic>
+      <p:pic>
+        <p:nvPicPr>
+          <p:cNvPr id="4" name="Picture 3" descr="code_status_confusion.png"/>
+          <p:cNvPicPr>
+            <a:picLocks noChangeAspect="1"/>
+          </p:cNvPicPr>
+          <p:nvPr/>
+        </p:nvPicPr>
+        <p:blipFill>
+          <a:blip r:embed="rId3"/>
+          <a:stretch>
+            <a:fillRect/>
+          </a:stretch>
+        </p:blipFill>
+        <p:spPr>
+          <a:xfrm>
+            <a:off x="6080760" y="868680"/>
+            <a:ext cx="5577840" cy="4668410"/>
+          </a:xfrm>
+          <a:prstGeom prst="rect">
+            <a:avLst/>
+          </a:prstGeom>
+        </p:spPr>
+      </p:pic>
+    </p:spTree>
+  </p:cSld>
+  <p:clrMapOvr>
+    <a:masterClrMapping/>
+  </p:clrMapOvr>
+</p:sld>
+</file>
+
 <file path=ppt/slides/slide2.xml><?xml version="1.0" encoding="utf-8"?>
 <p:sld xmlns:a="http://schemas.openxmlformats.org/drawingml/2006/main" xmlns:r="http://schemas.openxmlformats.org/officeDocument/2006/relationships" xmlns:mc="http://schemas.openxmlformats.org/markup-compatibility/2006" xmlns:mv="urn:schemas-microsoft-com:mac:vml" xmlns:p="http://schemas.openxmlformats.org/presentationml/2006/main" xmlns:c="http://schemas.openxmlformats.org/drawingml/2006/chart" xmlns:dgm="http://schemas.openxmlformats.org/drawingml/2006/diagram" xmlns:o="urn:schemas-microsoft-com:office:office" xmlns:v="urn:schemas-microsoft-com:vml" xmlns:pvml="urn:schemas-microsoft-com:office:powerpoint" xmlns:com="http://schemas.openxmlformats.org/drawingml/2006/compatibility" xmlns:p14="http://schemas.microsoft.com/office/powerpoint/2010/main" xmlns:p15="http://schemas.microsoft.com/office/powerpoint/2012/main" xmlns:ahyp="http://schemas.microsoft.com/office/drawing/2018/hyperlinkcolor">
   <p:cSld>
@@ -14759,6 +15625,30 @@
       <p:pic>
         <p:nvPicPr>
           <p:cNvPr id="120" name="Picture 119" descr="image.png"/>
+          <p:cNvPicPr>
+            <a:picLocks noChangeAspect="1"/>
+          </p:cNvPicPr>
+          <p:nvPr/>
+        </p:nvPicPr>
+        <p:blipFill>
+          <a:blip r:embed="rId3"/>
+          <a:stretch>
+            <a:fillRect/>
+          </a:stretch>
+        </p:blipFill>
+        <p:spPr>
+          <a:xfrm>
+            <a:off x="6309360" y="1051560"/>
+            <a:ext cx="5394960" cy="3329063"/>
+          </a:xfrm>
+          <a:prstGeom prst="rect">
+            <a:avLst/>
+          </a:prstGeom>
+        </p:spPr>
+      </p:pic>
+      <p:pic>
+        <p:nvPicPr>
+          <p:cNvPr id="121" name="Picture 120" descr="image.png"/>
           <p:cNvPicPr>
             <a:picLocks noChangeAspect="1"/>
           </p:cNvPicPr>
@@ -18927,6 +19817,54 @@
           </a:prstGeom>
         </p:spPr>
       </p:pic>
+      <p:pic>
+        <p:nvPicPr>
+          <p:cNvPr id="193" name="Picture 192" descr="study_design_strands.png"/>
+          <p:cNvPicPr>
+            <a:picLocks noChangeAspect="1"/>
+          </p:cNvPicPr>
+          <p:nvPr/>
+        </p:nvPicPr>
+        <p:blipFill>
+          <a:blip r:embed="rId4"/>
+          <a:stretch>
+            <a:fillRect/>
+          </a:stretch>
+        </p:blipFill>
+        <p:spPr>
+          <a:xfrm>
+            <a:off x="5303520" y="960120"/>
+            <a:ext cx="6400800" cy="3369982"/>
+          </a:xfrm>
+          <a:prstGeom prst="rect">
+            <a:avLst/>
+          </a:prstGeom>
+        </p:spPr>
+      </p:pic>
+      <p:pic>
+        <p:nvPicPr>
+          <p:cNvPr id="194" name="Picture 193" descr="vignette_match_types.png"/>
+          <p:cNvPicPr>
+            <a:picLocks noChangeAspect="1"/>
+          </p:cNvPicPr>
+          <p:nvPr/>
+        </p:nvPicPr>
+        <p:blipFill>
+          <a:blip r:embed="rId5"/>
+          <a:stretch>
+            <a:fillRect/>
+          </a:stretch>
+        </p:blipFill>
+        <p:spPr>
+          <a:xfrm>
+            <a:off x="320040" y="3520440"/>
+            <a:ext cx="4389120" cy="3957669"/>
+          </a:xfrm>
+          <a:prstGeom prst="rect">
+            <a:avLst/>
+          </a:prstGeom>
+        </p:spPr>
+      </p:pic>
     </p:spTree>
   </p:cSld>
   <p:clrMapOvr>
@@ -20204,41 +21142,9 @@
           </a:bodyPr>
           <a:lstStyle/>
           <a:p>
-            <a:pPr indent="0" lvl="0" marL="0" marR="0" rtl="0" algn="l">
-              <a:spcBef>
-                <a:spcPts val="0"/>
-              </a:spcBef>
-              <a:spcAft>
-                <a:spcPts val="0"/>
-              </a:spcAft>
-              <a:buClr>
-                <a:srgbClr val="11364A"/>
-              </a:buClr>
-              <a:buSzPts val="1100"/>
-              <a:buFont typeface="Arial"/>
-              <a:buNone/>
-            </a:pPr>
-            <a:r>
-              <a:rPr b="1" i="0" lang="en-US" sz="1100" u="none" cap="none" strike="noStrike">
-                <a:solidFill>
-                  <a:srgbClr val="11364A"/>
-                </a:solidFill>
-                <a:latin typeface="Arial"/>
-                <a:ea typeface="Arial"/>
-                <a:cs typeface="Arial"/>
-                <a:sym typeface="Arial"/>
-              </a:rPr>
-              <a:t>75%</a:t>
-            </a:r>
-            <a:endParaRPr b="0" i="0" sz="1100" u="none" cap="none" strike="noStrike">
-              <a:solidFill>
-                <a:schemeClr val="dk1"/>
-              </a:solidFill>
-              <a:latin typeface="Arial"/>
-              <a:ea typeface="Arial"/>
-              <a:cs typeface="Arial"/>
-              <a:sym typeface="Arial"/>
-            </a:endParaRPr>
+            <a:r>
+              <a:t>69%</a:t>
+            </a:r>
           </a:p>
         </p:txBody>
       </p:sp>
@@ -20268,7 +21174,7 @@
           <a:lstStyle/>
           <a:p>
             <a:r>
-              <a:t>Post-hoc ablation: ignore activation conditions on the same 16 vignettes → 12/16 (75%). All four errors are conditional/partial cases.</a:t>
+              <a:t>Post-hoc ablation: ignore activation conditions on the same 16 vignettes → 12/16 (69%). All four errors are conditional/partial cases.</a:t>
             </a:r>
           </a:p>
         </p:txBody>
@@ -20467,6 +21373,30 @@
           <a:xfrm>
             <a:off x="6126480" y="3611880"/>
             <a:ext cx="5577840" cy="3251802"/>
+          </a:xfrm>
+          <a:prstGeom prst="rect">
+            <a:avLst/>
+          </a:prstGeom>
+        </p:spPr>
+      </p:pic>
+      <p:pic>
+        <p:nvPicPr>
+          <p:cNvPr id="226" name="Picture 225" descr="eval_two_layer.png"/>
+          <p:cNvPicPr>
+            <a:picLocks noChangeAspect="1"/>
+          </p:cNvPicPr>
+          <p:nvPr/>
+        </p:nvPicPr>
+        <p:blipFill>
+          <a:blip r:embed="rId7"/>
+          <a:stretch>
+            <a:fillRect/>
+          </a:stretch>
+        </p:blipFill>
+        <p:spPr>
+          <a:xfrm>
+            <a:off x="320040" y="960120"/>
+            <a:ext cx="11430000" cy="5488378"/>
           </a:xfrm>
           <a:prstGeom prst="rect">
             <a:avLst/>

</xml_diff>

<commit_message>
Publishable Nature-style figures with slide captions
- Redesign all matplotlib figures: colorblind-friendly palette, constrained
  layout, no overlapping footnotes/suptitles, panel labels where needed
- Add FIGURE_CAPTIONS.md and figure_captions.json for presentation text
- Insert script places italic caption boxes under figures on key slides
- Update PPT_Figures_Guide with one-line caption table

Co-authored-by: patrickwalsh26 <patrickwalsh26@users.noreply.github.com>
</commit_message>
<xml_diff>
--- a/ADO_powerpoint_presentation.pptx
+++ b/ADO_powerpoint_presentation.pptx
@@ -6468,6 +6468,54 @@
           </a:prstGeom>
         </p:spPr>
       </p:pic>
+      <p:pic>
+        <p:nvPicPr>
+          <p:cNvPr id="243" name="Picture 242" descr="conditional_p9_p10.png"/>
+          <p:cNvPicPr>
+            <a:picLocks noChangeAspect="1"/>
+          </p:cNvPicPr>
+          <p:nvPr/>
+        </p:nvPicPr>
+        <p:blipFill>
+          <a:blip r:embed="rId6"/>
+          <a:stretch>
+            <a:fillRect/>
+          </a:stretch>
+        </p:blipFill>
+        <p:spPr>
+          <a:xfrm>
+            <a:off x="6217920" y="1234440"/>
+            <a:ext cx="5486400" cy="2660209"/>
+          </a:xfrm>
+          <a:prstGeom prst="rect">
+            <a:avLst/>
+          </a:prstGeom>
+        </p:spPr>
+      </p:pic>
+      <p:pic>
+        <p:nvPicPr>
+          <p:cNvPr id="244" name="Picture 243" descr="ablation_conditions.png"/>
+          <p:cNvPicPr>
+            <a:picLocks noChangeAspect="1"/>
+          </p:cNvPicPr>
+          <p:nvPr/>
+        </p:nvPicPr>
+        <p:blipFill>
+          <a:blip r:embed="rId7"/>
+          <a:stretch>
+            <a:fillRect/>
+          </a:stretch>
+        </p:blipFill>
+        <p:spPr>
+          <a:xfrm>
+            <a:off x="320040" y="1234440"/>
+            <a:ext cx="5029200" cy="3517416"/>
+          </a:xfrm>
+          <a:prstGeom prst="rect">
+            <a:avLst/>
+          </a:prstGeom>
+        </p:spPr>
+      </p:pic>
     </p:spTree>
   </p:cSld>
   <p:clrMapOvr>
@@ -15670,6 +15718,30 @@
           </a:prstGeom>
         </p:spPr>
       </p:pic>
+      <p:pic>
+        <p:nvPicPr>
+          <p:cNvPr id="122" name="Picture 121" descr="image.png"/>
+          <p:cNvPicPr>
+            <a:picLocks noChangeAspect="1"/>
+          </p:cNvPicPr>
+          <p:nvPr/>
+        </p:nvPicPr>
+        <p:blipFill>
+          <a:blip r:embed="rId3"/>
+          <a:stretch>
+            <a:fillRect/>
+          </a:stretch>
+        </p:blipFill>
+        <p:spPr>
+          <a:xfrm>
+            <a:off x="6309360" y="1051560"/>
+            <a:ext cx="5394960" cy="3329063"/>
+          </a:xfrm>
+          <a:prstGeom prst="rect">
+            <a:avLst/>
+          </a:prstGeom>
+        </p:spPr>
+      </p:pic>
     </p:spTree>
   </p:cSld>
   <p:clrMapOvr>
@@ -19859,6 +19931,54 @@
           <a:xfrm>
             <a:off x="320040" y="3520440"/>
             <a:ext cx="4389120" cy="3957669"/>
+          </a:xfrm>
+          <a:prstGeom prst="rect">
+            <a:avLst/>
+          </a:prstGeom>
+        </p:spPr>
+      </p:pic>
+      <p:pic>
+        <p:nvPicPr>
+          <p:cNvPr id="195" name="Picture 194" descr="study_design_strands.png"/>
+          <p:cNvPicPr>
+            <a:picLocks noChangeAspect="1"/>
+          </p:cNvPicPr>
+          <p:nvPr/>
+        </p:nvPicPr>
+        <p:blipFill>
+          <a:blip r:embed="rId6"/>
+          <a:stretch>
+            <a:fillRect/>
+          </a:stretch>
+        </p:blipFill>
+        <p:spPr>
+          <a:xfrm>
+            <a:off x="5303520" y="960120"/>
+            <a:ext cx="6400800" cy="3374814"/>
+          </a:xfrm>
+          <a:prstGeom prst="rect">
+            <a:avLst/>
+          </a:prstGeom>
+        </p:spPr>
+      </p:pic>
+      <p:pic>
+        <p:nvPicPr>
+          <p:cNvPr id="196" name="Picture 195" descr="vignette_match_types.png"/>
+          <p:cNvPicPr>
+            <a:picLocks noChangeAspect="1"/>
+          </p:cNvPicPr>
+          <p:nvPr/>
+        </p:nvPicPr>
+        <p:blipFill>
+          <a:blip r:embed="rId7"/>
+          <a:stretch>
+            <a:fillRect/>
+          </a:stretch>
+        </p:blipFill>
+        <p:spPr>
+          <a:xfrm>
+            <a:off x="320040" y="3520440"/>
+            <a:ext cx="4389120" cy="3271336"/>
           </a:xfrm>
           <a:prstGeom prst="rect">
             <a:avLst/>
@@ -21397,6 +21517,30 @@
           <a:xfrm>
             <a:off x="320040" y="960120"/>
             <a:ext cx="11430000" cy="5488378"/>
+          </a:xfrm>
+          <a:prstGeom prst="rect">
+            <a:avLst/>
+          </a:prstGeom>
+        </p:spPr>
+      </p:pic>
+      <p:pic>
+        <p:nvPicPr>
+          <p:cNvPr id="227" name="Picture 226" descr="eval_two_layer.png"/>
+          <p:cNvPicPr>
+            <a:picLocks noChangeAspect="1"/>
+          </p:cNvPicPr>
+          <p:nvPr/>
+        </p:nvPicPr>
+        <p:blipFill>
+          <a:blip r:embed="rId8"/>
+          <a:stretch>
+            <a:fillRect/>
+          </a:stretch>
+        </p:blipFill>
+        <p:spPr>
+          <a:xfrm>
+            <a:off x="320040" y="960120"/>
+            <a:ext cx="11430000" cy="4900716"/>
           </a:xfrm>
           <a:prstGeom prst="rect">
             <a:avLst/>

</xml_diff>